<commit_message>
edit ppt final checking
</commit_message>
<xml_diff>
--- a/docs/Presentation_Team_23_final.pptx
+++ b/docs/Presentation_Team_23_final.pptx
@@ -5,25 +5,23 @@
     <p:sldMasterId id="2147483648" r:id="rId1"/>
   </p:sldMasterIdLst>
   <p:notesMasterIdLst>
-    <p:notesMasterId r:id="rId18"/>
+    <p:notesMasterId r:id="rId16"/>
   </p:notesMasterIdLst>
   <p:sldIdLst>
     <p:sldId id="256" r:id="rId2"/>
     <p:sldId id="257" r:id="rId3"/>
-    <p:sldId id="258" r:id="rId4"/>
-    <p:sldId id="270" r:id="rId5"/>
-    <p:sldId id="259" r:id="rId6"/>
-    <p:sldId id="260" r:id="rId7"/>
-    <p:sldId id="261" r:id="rId8"/>
-    <p:sldId id="262" r:id="rId9"/>
-    <p:sldId id="263" r:id="rId10"/>
-    <p:sldId id="271" r:id="rId11"/>
-    <p:sldId id="264" r:id="rId12"/>
-    <p:sldId id="265" r:id="rId13"/>
-    <p:sldId id="266" r:id="rId14"/>
-    <p:sldId id="267" r:id="rId15"/>
-    <p:sldId id="268" r:id="rId16"/>
-    <p:sldId id="269" r:id="rId17"/>
+    <p:sldId id="272" r:id="rId4"/>
+    <p:sldId id="259" r:id="rId5"/>
+    <p:sldId id="260" r:id="rId6"/>
+    <p:sldId id="261" r:id="rId7"/>
+    <p:sldId id="262" r:id="rId8"/>
+    <p:sldId id="263" r:id="rId9"/>
+    <p:sldId id="264" r:id="rId10"/>
+    <p:sldId id="266" r:id="rId11"/>
+    <p:sldId id="267" r:id="rId12"/>
+    <p:sldId id="273" r:id="rId13"/>
+    <p:sldId id="268" r:id="rId14"/>
+    <p:sldId id="269" r:id="rId15"/>
   </p:sldIdLst>
   <p:sldSz cx="9144000" cy="5143500" type="screen16x9"/>
   <p:notesSz cx="5143500" cy="9144000"/>
@@ -126,8 +124,7 @@
           <p14:sldIdLst>
             <p14:sldId id="256"/>
             <p14:sldId id="257"/>
-            <p14:sldId id="258"/>
-            <p14:sldId id="270"/>
+            <p14:sldId id="272"/>
           </p14:sldIdLst>
         </p14:section>
         <p14:section name="Method" id="{5011FE1B-70C1-A57C-04BF-1D5829EC1B02}">
@@ -141,15 +138,14 @@
             <p14:sldId id="261"/>
             <p14:sldId id="262"/>
             <p14:sldId id="263"/>
-            <p14:sldId id="271"/>
             <p14:sldId id="264"/>
-            <p14:sldId id="265"/>
             <p14:sldId id="266"/>
+            <p14:sldId id="267"/>
+            <p14:sldId id="273"/>
           </p14:sldIdLst>
         </p14:section>
         <p14:section name="Wrap-up" id="{8F869065-D199-2B1D-7BA9-F9BE7B89F95A}">
           <p14:sldIdLst>
-            <p14:sldId id="267"/>
             <p14:sldId id="268"/>
             <p14:sldId id="269"/>
           </p14:sldIdLst>
@@ -196,7 +192,6 @@
           </a:p>
         </c:rich>
       </c:tx>
-      <c:layout/>
       <c:overlay val="0"/>
     </c:title>
     <c:autoTitleDeleted val="0"/>
@@ -260,7 +255,6 @@
             <c:showLeaderLines val="0"/>
             <c:extLst>
               <c:ext xmlns:c15="http://schemas.microsoft.com/office/drawing/2012/chart" uri="{CE6537A1-D6FC-4f65-9D91-7224C49458BB}">
-                <c15:layout/>
                 <c15:showLeaderLines val="0"/>
               </c:ext>
             </c:extLst>
@@ -372,7 +366,6 @@
             <c:showLeaderLines val="0"/>
             <c:extLst>
               <c:ext xmlns:c15="http://schemas.microsoft.com/office/drawing/2012/chart" uri="{CE6537A1-D6FC-4f65-9D91-7224C49458BB}">
-                <c15:layout/>
                 <c15:showLeaderLines val="0"/>
               </c:ext>
             </c:extLst>
@@ -546,7 +539,6 @@
     </c:plotArea>
     <c:legend>
       <c:legendPos val="b"/>
-      <c:layout/>
       <c:overlay val="0"/>
       <c:txPr>
         <a:bodyPr/>
@@ -615,7 +607,6 @@
           </a:p>
         </c:rich>
       </c:tx>
-      <c:layout/>
       <c:overlay val="0"/>
     </c:title>
     <c:autoTitleDeleted val="0"/>
@@ -679,7 +670,6 @@
             <c:showLeaderLines val="0"/>
             <c:extLst>
               <c:ext xmlns:c15="http://schemas.microsoft.com/office/drawing/2012/chart" uri="{CE6537A1-D6FC-4f65-9D91-7224C49458BB}">
-                <c15:layout/>
                 <c15:showLeaderLines val="0"/>
               </c:ext>
             </c:extLst>
@@ -779,7 +769,6 @@
             <c:showLeaderLines val="0"/>
             <c:extLst>
               <c:ext xmlns:c15="http://schemas.microsoft.com/office/drawing/2012/chart" uri="{CE6537A1-D6FC-4f65-9D91-7224C49458BB}">
-                <c15:layout/>
                 <c15:showLeaderLines val="0"/>
               </c:ext>
             </c:extLst>
@@ -941,7 +930,6 @@
     </c:plotArea>
     <c:legend>
       <c:legendPos val="b"/>
-      <c:layout/>
       <c:overlay val="0"/>
       <c:txPr>
         <a:bodyPr/>
@@ -1010,7 +998,6 @@
           </a:p>
         </c:rich>
       </c:tx>
-      <c:layout/>
       <c:overlay val="0"/>
     </c:title>
     <c:autoTitleDeleted val="0"/>
@@ -1158,7 +1145,6 @@
             <c:showLeaderLines val="0"/>
             <c:extLst>
               <c:ext xmlns:c15="http://schemas.microsoft.com/office/drawing/2012/chart" uri="{CE6537A1-D6FC-4f65-9D91-7224C49458BB}">
-                <c15:layout/>
                 <c15:showLeaderLines val="0"/>
               </c:ext>
             </c:extLst>
@@ -1386,7 +1372,6 @@
           </a:p>
         </c:rich>
       </c:tx>
-      <c:layout/>
       <c:overlay val="0"/>
     </c:title>
     <c:autoTitleDeleted val="0"/>
@@ -1536,7 +1521,6 @@
             <c:showLeaderLines val="0"/>
             <c:extLst>
               <c:ext xmlns:c15="http://schemas.microsoft.com/office/drawing/2012/chart" uri="{CE6537A1-D6FC-4f65-9D91-7224C49458BB}">
-                <c15:layout/>
                 <c15:showLeaderLines val="0"/>
               </c:ext>
             </c:extLst>
@@ -1776,7 +1760,6 @@
           </a:p>
         </c:rich>
       </c:tx>
-      <c:layout/>
       <c:overlay val="0"/>
     </c:title>
     <c:autoTitleDeleted val="0"/>
@@ -2188,7 +2171,6 @@
     </c:plotArea>
     <c:legend>
       <c:legendPos val="b"/>
-      <c:layout/>
       <c:overlay val="0"/>
       <c:txPr>
         <a:bodyPr/>
@@ -2419,7 +2401,7 @@
               <a:rPr lang="en-US"/>
               <a:t>1</a:t>
             </a:fld>
-            <a:endParaRPr lang="en-US"/>
+            <a:endParaRPr lang="en-US" dirty="0"/>
           </a:p>
         </p:txBody>
       </p:sp>
@@ -2504,7 +2486,7 @@
           <a:p>
             <a:fld id="{F7021451-1387-4CA6-816F-3879F97B5CBC}" type="slidenum">
               <a:rPr lang="en-US"/>
-              <a:t>13</a:t>
+              <a:t>10</a:t>
             </a:fld>
             <a:endParaRPr lang="en-US"/>
           </a:p>
@@ -2591,7 +2573,7 @@
           <a:p>
             <a:fld id="{F7021451-1387-4CA6-816F-3879F97B5CBC}" type="slidenum">
               <a:rPr lang="en-US"/>
-              <a:t>14</a:t>
+              <a:t>11</a:t>
             </a:fld>
             <a:endParaRPr lang="en-US"/>
           </a:p>
@@ -2615,7 +2597,13 @@
   <p:cSld>
     <p:spTree>
       <p:nvGrpSpPr>
-        <p:cNvPr id="1" name=""/>
+        <p:cNvPr id="1" name="">
+          <a:extLst>
+            <a:ext uri="{FF2B5EF4-FFF2-40B4-BE49-F238E27FC236}">
+              <a16:creationId xmlns:a16="http://schemas.microsoft.com/office/drawing/2014/main" id="{55DEFAAB-6B72-8FAE-0060-C31557833614}"/>
+            </a:ext>
+          </a:extLst>
+        </p:cNvPr>
         <p:cNvGrpSpPr/>
         <p:nvPr/>
       </p:nvGrpSpPr>
@@ -2629,7 +2617,13 @@
       </p:grpSpPr>
       <p:sp>
         <p:nvSpPr>
-          <p:cNvPr id="2" name="Slide Image Placeholder 1"/>
+          <p:cNvPr id="2" name="Slide Image Placeholder 1">
+            <a:extLst>
+              <a:ext uri="{FF2B5EF4-FFF2-40B4-BE49-F238E27FC236}">
+                <a16:creationId xmlns:a16="http://schemas.microsoft.com/office/drawing/2014/main" id="{E9741F16-3949-7A65-6177-210873C89940}"/>
+              </a:ext>
+            </a:extLst>
+          </p:cNvPr>
           <p:cNvSpPr>
             <a:spLocks noGrp="1" noRot="1" noChangeAspect="1"/>
           </p:cNvSpPr>
@@ -2641,7 +2635,13 @@
       </p:sp>
       <p:sp>
         <p:nvSpPr>
-          <p:cNvPr id="3" name="Notes Placeholder 2"/>
+          <p:cNvPr id="3" name="Notes Placeholder 2">
+            <a:extLst>
+              <a:ext uri="{FF2B5EF4-FFF2-40B4-BE49-F238E27FC236}">
+                <a16:creationId xmlns:a16="http://schemas.microsoft.com/office/drawing/2014/main" id="{3694A5FF-DC50-25D7-8999-D8394046E5DC}"/>
+              </a:ext>
+            </a:extLst>
+          </p:cNvPr>
           <p:cNvSpPr>
             <a:spLocks noGrp="1"/>
           </p:cNvSpPr>
@@ -2656,14 +2656,20 @@
           <a:p>
             <a:r>
               <a:rPr lang="en-US" dirty="0"/>
-              <a:t>Numbers in brackets are the notebook sections. Each of us should be ready to explain every section, but lead on our own parts during Q&amp;A.</a:t>
-            </a:r>
-          </a:p>
-        </p:txBody>
-      </p:sp>
-      <p:sp>
-        <p:nvSpPr>
-          <p:cNvPr id="4" name="Slide Number Placeholder 3"/>
+              <a:t>Final model chosen by repeated CV, not by the test set: Random Forest (tuned), feature set C. The test set has only 136 songs, so it is about plus or minus 4 points; CV is the more reliable comparison. The soft-voting ensemble did not beat the single Random Forest.</a:t>
+            </a:r>
+          </a:p>
+        </p:txBody>
+      </p:sp>
+      <p:sp>
+        <p:nvSpPr>
+          <p:cNvPr id="4" name="Slide Number Placeholder 3">
+            <a:extLst>
+              <a:ext uri="{FF2B5EF4-FFF2-40B4-BE49-F238E27FC236}">
+                <a16:creationId xmlns:a16="http://schemas.microsoft.com/office/drawing/2014/main" id="{0A76A2BC-F558-6957-BB15-D36B0EEE36D0}"/>
+              </a:ext>
+            </a:extLst>
+          </p:cNvPr>
           <p:cNvSpPr>
             <a:spLocks noGrp="1"/>
           </p:cNvSpPr>
@@ -2678,7 +2684,7 @@
           <a:p>
             <a:fld id="{F7021451-1387-4CA6-816F-3879F97B5CBC}" type="slidenum">
               <a:rPr lang="en-US"/>
-              <a:t>15</a:t>
+              <a:t>12</a:t>
             </a:fld>
             <a:endParaRPr lang="en-US"/>
           </a:p>
@@ -2687,7 +2693,7 @@
     </p:spTree>
     <p:extLst>
       <p:ext uri="{BB962C8B-B14F-4D97-AF65-F5344CB8AC3E}">
-        <p14:creationId xmlns:p14="http://schemas.microsoft.com/office/powerpoint/2010/main" val="1024086991"/>
+        <p14:creationId xmlns:p14="http://schemas.microsoft.com/office/powerpoint/2010/main" val="1281145702"/>
       </p:ext>
     </p:extLst>
   </p:cSld>
@@ -2743,7 +2749,7 @@
           <a:p>
             <a:r>
               <a:rPr lang="en-US" dirty="0"/>
-              <a:t>Summarise: replicated the paper's baselines, extended them, tuned them honestly with CV, and added a new-playlist rule and an app. Be ready for: why release_year matters so much; why we score below the paper (no genre tags); why Random Forest was chosen (repeated CV); how we avoided leakage (pipelines, train-only tuning).</a:t>
+              <a:t>Numbers in brackets are the notebook sections. Each of us should be ready to explain every section, but lead on our own parts during Q&amp;A.</a:t>
             </a:r>
           </a:p>
         </p:txBody>
@@ -2765,7 +2771,94 @@
           <a:p>
             <a:fld id="{F7021451-1387-4CA6-816F-3879F97B5CBC}" type="slidenum">
               <a:rPr lang="en-US"/>
-              <a:t>16</a:t>
+              <a:t>13</a:t>
+            </a:fld>
+            <a:endParaRPr lang="en-US"/>
+          </a:p>
+        </p:txBody>
+      </p:sp>
+    </p:spTree>
+    <p:extLst>
+      <p:ext uri="{BB962C8B-B14F-4D97-AF65-F5344CB8AC3E}">
+        <p14:creationId xmlns:p14="http://schemas.microsoft.com/office/powerpoint/2010/main" val="1024086991"/>
+      </p:ext>
+    </p:extLst>
+  </p:cSld>
+  <p:clrMapOvr>
+    <a:masterClrMapping/>
+  </p:clrMapOvr>
+</p:notes>
+</file>
+
+<file path=ppt/notesSlides/notesSlide14.xml><?xml version="1.0" encoding="utf-8"?>
+<p:notes xmlns:a="http://schemas.openxmlformats.org/drawingml/2006/main" xmlns:r="http://schemas.openxmlformats.org/officeDocument/2006/relationships" xmlns:p="http://schemas.openxmlformats.org/presentationml/2006/main">
+  <p:cSld>
+    <p:spTree>
+      <p:nvGrpSpPr>
+        <p:cNvPr id="1" name=""/>
+        <p:cNvGrpSpPr/>
+        <p:nvPr/>
+      </p:nvGrpSpPr>
+      <p:grpSpPr>
+        <a:xfrm>
+          <a:off x="0" y="0"/>
+          <a:ext cx="0" cy="0"/>
+          <a:chOff x="0" y="0"/>
+          <a:chExt cx="0" cy="0"/>
+        </a:xfrm>
+      </p:grpSpPr>
+      <p:sp>
+        <p:nvSpPr>
+          <p:cNvPr id="2" name="Slide Image Placeholder 1"/>
+          <p:cNvSpPr>
+            <a:spLocks noGrp="1" noRot="1" noChangeAspect="1"/>
+          </p:cNvSpPr>
+          <p:nvPr>
+            <p:ph type="sldImg"/>
+          </p:nvPr>
+        </p:nvSpPr>
+        <p:spPr/>
+      </p:sp>
+      <p:sp>
+        <p:nvSpPr>
+          <p:cNvPr id="3" name="Notes Placeholder 2"/>
+          <p:cNvSpPr>
+            <a:spLocks noGrp="1"/>
+          </p:cNvSpPr>
+          <p:nvPr>
+            <p:ph type="body" idx="1"/>
+          </p:nvPr>
+        </p:nvSpPr>
+        <p:spPr/>
+        <p:txBody>
+          <a:bodyPr/>
+          <a:lstStyle/>
+          <a:p>
+            <a:r>
+              <a:rPr lang="en-US" dirty="0"/>
+              <a:t>Summarise: replicated the paper's baselines, extended them, tuned them honestly with CV, and added a new-playlist rule and an app. Be ready for: why release_year matters so much; why we score below the paper (no genre tags); why Random Forest was chosen (repeated CV); how we avoided leakage (pipelines, train-only tuning).</a:t>
+            </a:r>
+          </a:p>
+        </p:txBody>
+      </p:sp>
+      <p:sp>
+        <p:nvSpPr>
+          <p:cNvPr id="4" name="Slide Number Placeholder 3"/>
+          <p:cNvSpPr>
+            <a:spLocks noGrp="1"/>
+          </p:cNvSpPr>
+          <p:nvPr>
+            <p:ph type="sldNum" sz="quarter" idx="10"/>
+          </p:nvPr>
+        </p:nvSpPr>
+        <p:spPr/>
+        <p:txBody>
+          <a:bodyPr/>
+          <a:lstStyle/>
+          <a:p>
+            <a:fld id="{F7021451-1387-4CA6-816F-3879F97B5CBC}" type="slidenum">
+              <a:rPr lang="en-US"/>
+              <a:t>14</a:t>
             </a:fld>
             <a:endParaRPr lang="en-US"/>
           </a:p>
@@ -2854,7 +2947,7 @@
               <a:rPr lang="en-US"/>
               <a:t>2</a:t>
             </a:fld>
-            <a:endParaRPr lang="en-US"/>
+            <a:endParaRPr lang="en-US" dirty="0"/>
           </a:p>
         </p:txBody>
       </p:sp>
@@ -2876,7 +2969,13 @@
   <p:cSld>
     <p:spTree>
       <p:nvGrpSpPr>
-        <p:cNvPr id="1" name=""/>
+        <p:cNvPr id="1" name="">
+          <a:extLst>
+            <a:ext uri="{FF2B5EF4-FFF2-40B4-BE49-F238E27FC236}">
+              <a16:creationId xmlns:a16="http://schemas.microsoft.com/office/drawing/2014/main" id="{9699F4DA-86DB-F065-ECD1-484347A289AC}"/>
+            </a:ext>
+          </a:extLst>
+        </p:cNvPr>
         <p:cNvGrpSpPr/>
         <p:nvPr/>
       </p:nvGrpSpPr>
@@ -2890,7 +2989,13 @@
       </p:grpSpPr>
       <p:sp>
         <p:nvSpPr>
-          <p:cNvPr id="2" name="Slide Image Placeholder 1"/>
+          <p:cNvPr id="2" name="Slide Image Placeholder 1">
+            <a:extLst>
+              <a:ext uri="{FF2B5EF4-FFF2-40B4-BE49-F238E27FC236}">
+                <a16:creationId xmlns:a16="http://schemas.microsoft.com/office/drawing/2014/main" id="{545ECFBF-F82E-CA8A-3F52-42029BA4A86B}"/>
+              </a:ext>
+            </a:extLst>
+          </p:cNvPr>
           <p:cNvSpPr>
             <a:spLocks noGrp="1" noRot="1" noChangeAspect="1"/>
           </p:cNvSpPr>
@@ -2902,7 +3007,13 @@
       </p:sp>
       <p:sp>
         <p:nvSpPr>
-          <p:cNvPr id="3" name="Notes Placeholder 2"/>
+          <p:cNvPr id="3" name="Notes Placeholder 2">
+            <a:extLst>
+              <a:ext uri="{FF2B5EF4-FFF2-40B4-BE49-F238E27FC236}">
+                <a16:creationId xmlns:a16="http://schemas.microsoft.com/office/drawing/2014/main" id="{B5C5ECF0-C9A3-352F-C8F1-C6C50DCDDDA4}"/>
+              </a:ext>
+            </a:extLst>
+          </p:cNvPr>
           <p:cNvSpPr>
             <a:spLocks noGrp="1"/>
           </p:cNvSpPr>
@@ -2924,7 +3035,13 @@
       </p:sp>
       <p:sp>
         <p:nvSpPr>
-          <p:cNvPr id="4" name="Slide Number Placeholder 3"/>
+          <p:cNvPr id="4" name="Slide Number Placeholder 3">
+            <a:extLst>
+              <a:ext uri="{FF2B5EF4-FFF2-40B4-BE49-F238E27FC236}">
+                <a16:creationId xmlns:a16="http://schemas.microsoft.com/office/drawing/2014/main" id="{D7B3A433-F573-F286-8E27-A38DF5E68986}"/>
+              </a:ext>
+            </a:extLst>
+          </p:cNvPr>
           <p:cNvSpPr>
             <a:spLocks noGrp="1"/>
           </p:cNvSpPr>
@@ -2941,14 +3058,14 @@
               <a:rPr lang="en-US"/>
               <a:t>3</a:t>
             </a:fld>
-            <a:endParaRPr lang="en-US"/>
+            <a:endParaRPr lang="en-US" dirty="0"/>
           </a:p>
         </p:txBody>
       </p:sp>
     </p:spTree>
     <p:extLst>
       <p:ext uri="{BB962C8B-B14F-4D97-AF65-F5344CB8AC3E}">
-        <p14:creationId xmlns:p14="http://schemas.microsoft.com/office/powerpoint/2010/main" val="1024086991"/>
+        <p14:creationId xmlns:p14="http://schemas.microsoft.com/office/powerpoint/2010/main" val="2509219206"/>
       </p:ext>
     </p:extLst>
   </p:cSld>
@@ -3026,7 +3143,7 @@
           <a:p>
             <a:fld id="{F7021451-1387-4CA6-816F-3879F97B5CBC}" type="slidenum">
               <a:rPr lang="en-US"/>
-              <a:t>5</a:t>
+              <a:t>4</a:t>
             </a:fld>
             <a:endParaRPr lang="en-US"/>
           </a:p>
@@ -3113,7 +3230,7 @@
           <a:p>
             <a:fld id="{F7021451-1387-4CA6-816F-3879F97B5CBC}" type="slidenum">
               <a:rPr lang="en-US"/>
-              <a:t>6</a:t>
+              <a:t>5</a:t>
             </a:fld>
             <a:endParaRPr lang="en-US"/>
           </a:p>
@@ -3200,7 +3317,7 @@
           <a:p>
             <a:fld id="{F7021451-1387-4CA6-816F-3879F97B5CBC}" type="slidenum">
               <a:rPr lang="en-US"/>
-              <a:t>7</a:t>
+              <a:t>6</a:t>
             </a:fld>
             <a:endParaRPr lang="en-US"/>
           </a:p>
@@ -3287,7 +3404,7 @@
           <a:p>
             <a:fld id="{F7021451-1387-4CA6-816F-3879F97B5CBC}" type="slidenum">
               <a:rPr lang="en-US"/>
-              <a:t>8</a:t>
+              <a:t>7</a:t>
             </a:fld>
             <a:endParaRPr lang="en-US"/>
           </a:p>
@@ -3374,7 +3491,7 @@
           <a:p>
             <a:fld id="{F7021451-1387-4CA6-816F-3879F97B5CBC}" type="slidenum">
               <a:rPr lang="en-US"/>
-              <a:t>9</a:t>
+              <a:t>8</a:t>
             </a:fld>
             <a:endParaRPr lang="en-US"/>
           </a:p>
@@ -3461,7 +3578,7 @@
           <a:p>
             <a:fld id="{F7021451-1387-4CA6-816F-3879F97B5CBC}" type="slidenum">
               <a:rPr lang="en-US"/>
-              <a:t>11</a:t>
+              <a:t>9</a:t>
             </a:fld>
             <a:endParaRPr lang="en-US"/>
           </a:p>
@@ -3747,7 +3864,7 @@
           </a:prstGeom>
           <a:extLst>
             <a:ext uri="{C572A759-6A51-4108-AA02-DFA0A04FC94B}">
-              <ma14:wrappingTextBoxFlag xmlns="" xmlns:ma14="http://schemas.microsoft.com/office/mac/drawingml/2011/main" val="0"/>
+              <ma14:wrappingTextBoxFlag xmlns:ma14="http://schemas.microsoft.com/office/mac/drawingml/2011/main" xmlns="" val="0"/>
             </a:ext>
           </a:extLst>
         </p:spPr>
@@ -3866,7 +3983,7 @@
           </a:prstGeom>
           <a:extLst>
             <a:ext uri="{C572A759-6A51-4108-AA02-DFA0A04FC94B}">
-              <ma14:wrappingTextBoxFlag xmlns="" xmlns:ma14="http://schemas.microsoft.com/office/mac/drawingml/2011/main" val="0"/>
+              <ma14:wrappingTextBoxFlag xmlns:ma14="http://schemas.microsoft.com/office/mac/drawingml/2011/main" xmlns="" val="0"/>
             </a:ext>
           </a:extLst>
         </p:spPr>
@@ -3941,7 +4058,7 @@
           </a:prstGeom>
           <a:extLst>
             <a:ext uri="{C572A759-6A51-4108-AA02-DFA0A04FC94B}">
-              <ma14:wrappingTextBoxFlag xmlns="" xmlns:ma14="http://schemas.microsoft.com/office/mac/drawingml/2011/main" val="0"/>
+              <ma14:wrappingTextBoxFlag xmlns:ma14="http://schemas.microsoft.com/office/mac/drawingml/2011/main" xmlns="" val="0"/>
             </a:ext>
           </a:extLst>
         </p:spPr>
@@ -4334,7 +4451,7 @@
         </p:nvSpPr>
         <p:spPr>
           <a:xfrm>
-            <a:off x="548640" y="3886200"/>
+            <a:off x="548640" y="3662302"/>
             <a:ext cx="4937760" cy="640080"/>
           </a:xfrm>
           <a:prstGeom prst="rect">
@@ -4356,9 +4473,8 @@
                   <a:schemeClr val="bg1"/>
                 </a:solidFill>
               </a:rPr>
-              <a:t>Rekha Dhorigol  PES1UG24CS370</a:t>
-            </a:r>
-            <a:endParaRPr lang="en-US" sz="1600" dirty="0"/>
+              <a:t>Team 23:</a:t>
+            </a:r>
           </a:p>
           <a:p>
             <a:pPr marL="0" indent="0">
@@ -4370,7 +4486,21 @@
                   <a:schemeClr val="bg1"/>
                 </a:solidFill>
               </a:rPr>
-              <a:t>Sai Manogna B V  PES1UG24CS399</a:t>
+              <a:t>Rekha Dhorigol - PES1UG24CS370</a:t>
+            </a:r>
+            <a:endParaRPr lang="en-US" sz="1600" dirty="0"/>
+          </a:p>
+          <a:p>
+            <a:pPr marL="0" indent="0">
+              <a:buNone/>
+            </a:pPr>
+            <a:r>
+              <a:rPr lang="en-US" sz="1600" dirty="0">
+                <a:solidFill>
+                  <a:schemeClr val="bg1"/>
+                </a:solidFill>
+              </a:rPr>
+              <a:t>Sai Manogna B V - PES1UG24CS399</a:t>
             </a:r>
             <a:endParaRPr lang="en-US" sz="1600" dirty="0"/>
           </a:p>
@@ -4485,662 +4615,10 @@
   <p:clrMapOvr>
     <a:masterClrMapping/>
   </p:clrMapOvr>
-  <p:timing>
-    <p:tnLst>
-      <p:par>
-        <p:cTn id="1" dur="indefinite" restart="never" nodeType="tmRoot"/>
-      </p:par>
-    </p:tnLst>
-  </p:timing>
 </p:sld>
 </file>
 
 <file path=ppt/slides/slide10.xml><?xml version="1.0" encoding="utf-8"?>
-<p:sld xmlns:a="http://schemas.openxmlformats.org/drawingml/2006/main" xmlns:r="http://schemas.openxmlformats.org/officeDocument/2006/relationships" xmlns:p="http://schemas.openxmlformats.org/presentationml/2006/main">
-  <p:cSld>
-    <p:spTree>
-      <p:nvGrpSpPr>
-        <p:cNvPr id="1" name=""/>
-        <p:cNvGrpSpPr/>
-        <p:nvPr/>
-      </p:nvGrpSpPr>
-      <p:grpSpPr>
-        <a:xfrm>
-          <a:off x="0" y="0"/>
-          <a:ext cx="0" cy="0"/>
-          <a:chOff x="0" y="0"/>
-          <a:chExt cx="0" cy="0"/>
-        </a:xfrm>
-      </p:grpSpPr>
-      <p:sp>
-        <p:nvSpPr>
-          <p:cNvPr id="2" name="Title 1"/>
-          <p:cNvSpPr>
-            <a:spLocks noGrp="1"/>
-          </p:cNvSpPr>
-          <p:nvPr>
-            <p:ph type="title" idx="100"/>
-          </p:nvPr>
-        </p:nvSpPr>
-        <p:spPr/>
-        <p:txBody>
-          <a:bodyPr/>
-          <a:lstStyle/>
-          <a:p>
-            <a:r>
-              <a:rPr lang="en-IN" sz="2800" dirty="0" smtClean="0"/>
-              <a:t>O</a:t>
-            </a:r>
-            <a:r>
-              <a:rPr sz="2800" dirty="0" err="1" smtClean="0"/>
-              <a:t>ur</a:t>
-            </a:r>
-            <a:r>
-              <a:rPr sz="2800" dirty="0" smtClean="0"/>
-              <a:t> novelty and what the results actually show </a:t>
-            </a:r>
-            <a:endParaRPr sz="2800" dirty="0"/>
-          </a:p>
-        </p:txBody>
-      </p:sp>
-      <p:sp>
-        <p:nvSpPr>
-          <p:cNvPr id="5" name="Rounded Rectangle 4"/>
-          <p:cNvSpPr/>
-          <p:nvPr/>
-        </p:nvSpPr>
-        <p:spPr>
-          <a:xfrm>
-            <a:off x="0" y="1158530"/>
-            <a:ext cx="8672513" cy="3614729"/>
-          </a:xfrm>
-          <a:prstGeom prst="roundRect">
-            <a:avLst/>
-          </a:prstGeom>
-          <a:solidFill>
-            <a:srgbClr val="F7F9FC"/>
-          </a:solidFill>
-          <a:ln>
-            <a:solidFill>
-              <a:srgbClr val="D7E0EA"/>
-            </a:solidFill>
-          </a:ln>
-        </p:spPr>
-        <p:style>
-          <a:lnRef idx="1">
-            <a:schemeClr val="accent1"/>
-          </a:lnRef>
-          <a:fillRef idx="3">
-            <a:schemeClr val="accent1"/>
-          </a:fillRef>
-          <a:effectRef idx="2">
-            <a:schemeClr val="accent1"/>
-          </a:effectRef>
-          <a:fontRef idx="minor">
-            <a:schemeClr val="lt1"/>
-          </a:fontRef>
-        </p:style>
-        <p:txBody>
-          <a:bodyPr rtlCol="0" anchor="ctr"/>
-          <a:lstStyle/>
-          <a:p>
-            <a:pPr algn="ctr"/>
-            <a:endParaRPr/>
-          </a:p>
-        </p:txBody>
-      </p:sp>
-      <p:sp>
-        <p:nvSpPr>
-          <p:cNvPr id="6" name="TextBox 5"/>
-          <p:cNvSpPr txBox="1"/>
-          <p:nvPr/>
-        </p:nvSpPr>
-        <p:spPr>
-          <a:xfrm>
-            <a:off x="262034" y="1178342"/>
-            <a:ext cx="5029200" cy="365760"/>
-          </a:xfrm>
-          <a:prstGeom prst="rect">
-            <a:avLst/>
-          </a:prstGeom>
-          <a:noFill/>
-        </p:spPr>
-        <p:txBody>
-          <a:bodyPr wrap="none">
-            <a:spAutoFit/>
-          </a:bodyPr>
-          <a:lstStyle/>
-          <a:p>
-            <a:pPr>
-              <a:defRPr sz="1800" b="1">
-                <a:solidFill>
-                  <a:srgbClr val="193052"/>
-                </a:solidFill>
-              </a:defRPr>
-            </a:pPr>
-            <a:r>
-              <a:rPr dirty="0"/>
-              <a:t>What is new in our approach?</a:t>
-            </a:r>
-          </a:p>
-        </p:txBody>
-      </p:sp>
-      <p:sp>
-        <p:nvSpPr>
-          <p:cNvPr id="7" name="TextBox 6"/>
-          <p:cNvSpPr txBox="1"/>
-          <p:nvPr/>
-        </p:nvSpPr>
-        <p:spPr>
-          <a:xfrm>
-            <a:off x="71057" y="1654211"/>
-            <a:ext cx="4983480" cy="603504"/>
-          </a:xfrm>
-          <a:prstGeom prst="rect">
-            <a:avLst/>
-          </a:prstGeom>
-          <a:noFill/>
-        </p:spPr>
-        <p:txBody>
-          <a:bodyPr wrap="square">
-            <a:spAutoFit/>
-          </a:bodyPr>
-          <a:lstStyle/>
-          <a:p>
-            <a:pPr>
-              <a:defRPr sz="1200" b="1">
-                <a:solidFill>
-                  <a:srgbClr val="3769A0"/>
-                </a:solidFill>
-              </a:defRPr>
-            </a:pPr>
-            <a:r>
-              <a:rPr dirty="0"/>
-              <a:t>Feature engineering:</a:t>
-            </a:r>
-          </a:p>
-          <a:p>
-            <a:pPr>
-              <a:defRPr sz="1050">
-                <a:solidFill>
-                  <a:srgbClr val="2D343C"/>
-                </a:solidFill>
-              </a:defRPr>
-            </a:pPr>
-            <a:r>
-              <a:rPr dirty="0"/>
-              <a:t> three audio-feature ratios plus metadata such as popularity, duration and release year.</a:t>
-            </a:r>
-          </a:p>
-        </p:txBody>
-      </p:sp>
-      <p:sp>
-        <p:nvSpPr>
-          <p:cNvPr id="8" name="TextBox 7"/>
-          <p:cNvSpPr txBox="1"/>
-          <p:nvPr/>
-        </p:nvSpPr>
-        <p:spPr>
-          <a:xfrm>
-            <a:off x="53671" y="2240189"/>
-            <a:ext cx="4983480" cy="603504"/>
-          </a:xfrm>
-          <a:prstGeom prst="rect">
-            <a:avLst/>
-          </a:prstGeom>
-          <a:noFill/>
-        </p:spPr>
-        <p:txBody>
-          <a:bodyPr wrap="square">
-            <a:spAutoFit/>
-          </a:bodyPr>
-          <a:lstStyle/>
-          <a:p>
-            <a:pPr>
-              <a:defRPr sz="1200" b="1">
-                <a:solidFill>
-                  <a:srgbClr val="3769A0"/>
-                </a:solidFill>
-              </a:defRPr>
-            </a:pPr>
-            <a:r>
-              <a:rPr dirty="0"/>
-              <a:t>Model exploration:</a:t>
-            </a:r>
-          </a:p>
-          <a:p>
-            <a:pPr>
-              <a:defRPr sz="1050">
-                <a:solidFill>
-                  <a:srgbClr val="2D343C"/>
-                </a:solidFill>
-              </a:defRPr>
-            </a:pPr>
-            <a:r>
-              <a:rPr dirty="0"/>
-              <a:t> tuned tree ensembles compared with the paper’s Perceptron/SVM/NN baselines; Random Forest led our CV.</a:t>
-            </a:r>
-          </a:p>
-        </p:txBody>
-      </p:sp>
-      <p:sp>
-        <p:nvSpPr>
-          <p:cNvPr id="9" name="TextBox 8"/>
-          <p:cNvSpPr txBox="1"/>
-          <p:nvPr/>
-        </p:nvSpPr>
-        <p:spPr>
-          <a:xfrm>
-            <a:off x="36285" y="2839067"/>
-            <a:ext cx="4983480" cy="603504"/>
-          </a:xfrm>
-          <a:prstGeom prst="rect">
-            <a:avLst/>
-          </a:prstGeom>
-          <a:noFill/>
-        </p:spPr>
-        <p:txBody>
-          <a:bodyPr wrap="square">
-            <a:spAutoFit/>
-          </a:bodyPr>
-          <a:lstStyle/>
-          <a:p>
-            <a:pPr>
-              <a:defRPr sz="1200" b="1">
-                <a:solidFill>
-                  <a:srgbClr val="3769A0"/>
-                </a:solidFill>
-              </a:defRPr>
-            </a:pPr>
-            <a:r>
-              <a:rPr dirty="0"/>
-              <a:t>Leakage-aware evaluation:</a:t>
-            </a:r>
-          </a:p>
-          <a:p>
-            <a:pPr>
-              <a:defRPr sz="1050">
-                <a:solidFill>
-                  <a:srgbClr val="2D343C"/>
-                </a:solidFill>
-              </a:defRPr>
-            </a:pPr>
-            <a:r>
-              <a:rPr dirty="0"/>
-              <a:t> preprocessing, feature selection and tuning are kept within training/CV pipelines; test set reported once.</a:t>
-            </a:r>
-          </a:p>
-        </p:txBody>
-      </p:sp>
-      <p:sp>
-        <p:nvSpPr>
-          <p:cNvPr id="10" name="TextBox 9"/>
-          <p:cNvSpPr txBox="1"/>
-          <p:nvPr/>
-        </p:nvSpPr>
-        <p:spPr>
-          <a:xfrm>
-            <a:off x="0" y="3474822"/>
-            <a:ext cx="4983480" cy="603504"/>
-          </a:xfrm>
-          <a:prstGeom prst="rect">
-            <a:avLst/>
-          </a:prstGeom>
-          <a:noFill/>
-        </p:spPr>
-        <p:txBody>
-          <a:bodyPr wrap="square">
-            <a:spAutoFit/>
-          </a:bodyPr>
-          <a:lstStyle/>
-          <a:p>
-            <a:pPr>
-              <a:defRPr sz="1200" b="1">
-                <a:solidFill>
-                  <a:srgbClr val="3769A0"/>
-                </a:solidFill>
-              </a:defRPr>
-            </a:pPr>
-            <a:r>
-              <a:rPr dirty="0"/>
-              <a:t>Confidence-aware output:</a:t>
-            </a:r>
-          </a:p>
-          <a:p>
-            <a:pPr>
-              <a:defRPr sz="1050">
-                <a:solidFill>
-                  <a:srgbClr val="2D343C"/>
-                </a:solidFill>
-              </a:defRPr>
-            </a:pPr>
-            <a:r>
-              <a:rPr dirty="0"/>
-              <a:t> low-confidence predictions trigger a new-playlist suggestion instead of forcing a weak label.</a:t>
-            </a:r>
-          </a:p>
-        </p:txBody>
-      </p:sp>
-      <p:sp>
-        <p:nvSpPr>
-          <p:cNvPr id="17" name="Rectangle 16"/>
-          <p:cNvSpPr/>
-          <p:nvPr/>
-        </p:nvSpPr>
-        <p:spPr>
-          <a:xfrm>
-            <a:off x="502920" y="6510528"/>
-            <a:ext cx="11109960" cy="16459"/>
-          </a:xfrm>
-          <a:prstGeom prst="rect">
-            <a:avLst/>
-          </a:prstGeom>
-          <a:solidFill>
-            <a:srgbClr val="EBF2F9"/>
-          </a:solidFill>
-          <a:ln>
-            <a:noFill/>
-          </a:ln>
-        </p:spPr>
-        <p:style>
-          <a:lnRef idx="1">
-            <a:schemeClr val="accent1"/>
-          </a:lnRef>
-          <a:fillRef idx="3">
-            <a:schemeClr val="accent1"/>
-          </a:fillRef>
-          <a:effectRef idx="2">
-            <a:schemeClr val="accent1"/>
-          </a:effectRef>
-          <a:fontRef idx="minor">
-            <a:schemeClr val="lt1"/>
-          </a:fontRef>
-        </p:style>
-        <p:txBody>
-          <a:bodyPr rtlCol="0" anchor="ctr"/>
-          <a:lstStyle/>
-          <a:p>
-            <a:pPr algn="ctr"/>
-            <a:endParaRPr/>
-          </a:p>
-        </p:txBody>
-      </p:sp>
-      <p:sp>
-        <p:nvSpPr>
-          <p:cNvPr id="18" name="TextBox 17"/>
-          <p:cNvSpPr txBox="1"/>
-          <p:nvPr/>
-        </p:nvSpPr>
-        <p:spPr>
-          <a:xfrm>
-            <a:off x="11155680" y="6556248"/>
-            <a:ext cx="411480" cy="164592"/>
-          </a:xfrm>
-          <a:prstGeom prst="rect">
-            <a:avLst/>
-          </a:prstGeom>
-          <a:noFill/>
-        </p:spPr>
-        <p:txBody>
-          <a:bodyPr wrap="none">
-            <a:spAutoFit/>
-          </a:bodyPr>
-          <a:lstStyle/>
-          <a:p>
-            <a:pPr algn="r">
-              <a:defRPr sz="900">
-                <a:solidFill>
-                  <a:srgbClr val="5F6976"/>
-                </a:solidFill>
-              </a:defRPr>
-            </a:pPr>
-            <a:r>
-              <a:t>9</a:t>
-            </a:r>
-          </a:p>
-        </p:txBody>
-      </p:sp>
-    </p:spTree>
-  </p:cSld>
-  <p:clrMapOvr>
-    <a:masterClrMapping/>
-  </p:clrMapOvr>
-  <p:timing>
-    <p:tnLst>
-      <p:par>
-        <p:cTn id="1" dur="indefinite" restart="never" nodeType="tmRoot"/>
-      </p:par>
-    </p:tnLst>
-  </p:timing>
-</p:sld>
-</file>
-
-<file path=ppt/slides/slide11.xml><?xml version="1.0" encoding="utf-8"?>
-<p:sld xmlns:a="http://schemas.openxmlformats.org/drawingml/2006/main" xmlns:r="http://schemas.openxmlformats.org/officeDocument/2006/relationships" xmlns:p="http://schemas.openxmlformats.org/presentationml/2006/main">
-  <p:cSld name="Slide 9">
-    <p:spTree>
-      <p:nvGrpSpPr>
-        <p:cNvPr id="1" name=""/>
-        <p:cNvGrpSpPr/>
-        <p:nvPr/>
-      </p:nvGrpSpPr>
-      <p:grpSpPr>
-        <a:xfrm>
-          <a:off x="0" y="0"/>
-          <a:ext cx="0" cy="0"/>
-          <a:chOff x="0" y="0"/>
-          <a:chExt cx="0" cy="0"/>
-        </a:xfrm>
-      </p:grpSpPr>
-      <p:sp>
-        <p:nvSpPr>
-          <p:cNvPr id="2" name="Text 0"/>
-          <p:cNvSpPr>
-            <a:spLocks noGrp="1"/>
-          </p:cNvSpPr>
-          <p:nvPr>
-            <p:ph type="title" idx="100" hasCustomPrompt="1"/>
-          </p:nvPr>
-        </p:nvSpPr>
-        <p:spPr>
-          <a:xfrm>
-            <a:off x="548640" y="274320"/>
-            <a:ext cx="8046720" cy="731520"/>
-          </a:xfrm>
-          <a:prstGeom prst="rect">
-            <a:avLst/>
-          </a:prstGeom>
-          <a:noFill/>
-          <a:ln/>
-        </p:spPr>
-        <p:txBody>
-          <a:bodyPr wrap="square" lIns="0" tIns="0" rIns="0" bIns="0" rtlCol="0" anchor="ctr"/>
-          <a:lstStyle/>
-          <a:p>
-            <a:pPr marL="0" indent="0" algn="l">
-              <a:buNone/>
-            </a:pPr>
-            <a:r>
-              <a:rPr lang="en-US" sz="3000" b="1" dirty="0">
-                <a:solidFill>
-                  <a:schemeClr val="tx1"/>
-                </a:solidFill>
-              </a:rPr>
-              <a:t>What drives it, what confuses it</a:t>
-            </a:r>
-            <a:endParaRPr lang="en-US" sz="3000" dirty="0"/>
-          </a:p>
-        </p:txBody>
-      </p:sp>
-      <p:graphicFrame>
-        <p:nvGraphicFramePr>
-          <p:cNvPr id="3" name="Chart 0"/>
-          <p:cNvGraphicFramePr/>
-          <p:nvPr/>
-        </p:nvGraphicFramePr>
-        <p:xfrm>
-          <a:off x="365760" y="1097280"/>
-          <a:ext cx="4023360" cy="3017520"/>
-        </p:xfrm>
-        <a:graphic>
-          <a:graphicData uri="http://schemas.openxmlformats.org/drawingml/2006/chart">
-            <c:chart xmlns:c="http://schemas.openxmlformats.org/drawingml/2006/chart" xmlns:r="http://schemas.openxmlformats.org/officeDocument/2006/relationships" r:id="rId3"/>
-          </a:graphicData>
-        </a:graphic>
-      </p:graphicFrame>
-      <p:pic>
-        <p:nvPicPr>
-          <p:cNvPr id="4" name="Image 0" descr="Normalised confusion matrix of the final Random Forest on the test set"/>
-          <p:cNvPicPr>
-            <a:picLocks noChangeAspect="1"/>
-          </p:cNvPicPr>
-          <p:nvPr/>
-        </p:nvPicPr>
-        <p:blipFill>
-          <a:blip r:embed="rId4"/>
-          <a:stretch>
-            <a:fillRect/>
-          </a:stretch>
-        </p:blipFill>
-        <p:spPr>
-          <a:xfrm>
-            <a:off x="4526280" y="1097280"/>
-            <a:ext cx="4206240" cy="3569205"/>
-          </a:xfrm>
-          <a:prstGeom prst="rect">
-            <a:avLst/>
-          </a:prstGeom>
-        </p:spPr>
-      </p:pic>
-      <p:sp>
-        <p:nvSpPr>
-          <p:cNvPr id="5" name="drivers_note"/>
-          <p:cNvSpPr txBox="1"/>
-          <p:nvPr/>
-        </p:nvSpPr>
-        <p:spPr>
-          <a:xfrm>
-            <a:off x="548640" y="4114800"/>
-            <a:ext cx="4023360" cy="594360"/>
-          </a:xfrm>
-          <a:prstGeom prst="rect">
-            <a:avLst/>
-          </a:prstGeom>
-          <a:noFill/>
-          <a:ln/>
-        </p:spPr>
-        <p:txBody>
-          <a:bodyPr wrap="square" lIns="0" tIns="0" rIns="0" bIns="0" rtlCol="0" anchor="t"/>
-          <a:lstStyle/>
-          <a:p>
-            <a:pPr marL="0" indent="0">
-              <a:buNone/>
-            </a:pPr>
-            <a:r>
-              <a:rPr lang="en-US" sz="1200" dirty="0">
-                <a:solidFill>
-                  <a:schemeClr val="tx1"/>
-                </a:solidFill>
-              </a:rPr>
-              <a:t>release_year dominates: several playlists are era-themed. Near-duplicate playlists (Charts 2020 vs 2020 Hits, Neo-Soul vs Urban Contemporary) get mixed up.</a:t>
-            </a:r>
-            <a:endParaRPr lang="en-US" sz="1200" dirty="0"/>
-          </a:p>
-        </p:txBody>
-      </p:sp>
-      <p:sp>
-        <p:nvSpPr>
-          <p:cNvPr id="25" name="Slide Number Placeholder 0"/>
-          <p:cNvSpPr>
-            <a:spLocks noGrp="1"/>
-          </p:cNvSpPr>
-          <p:nvPr>
-            <p:ph type="sldNum" sz="quarter" idx="4294967295"/>
-          </p:nvPr>
-        </p:nvSpPr>
-        <p:spPr>
-          <a:xfrm>
-            <a:off x="8229600" y="4754880"/>
-            <a:ext cx="365760" cy="274320"/>
-          </a:xfrm>
-          <a:prstGeom prst="rect">
-            <a:avLst/>
-          </a:prstGeom>
-          <a:extLst>
-            <a:ext uri="{C572A759-6A51-4108-AA02-DFA0A04FC94B}">
-              <ma14:wrappingTextBoxFlag xmlns="" xmlns:ma14="http://schemas.microsoft.com/office/mac/drawingml/2011/main" val="0"/>
-            </a:ext>
-          </a:extLst>
-        </p:spPr>
-        <p:txBody>
-          <a:bodyPr/>
-          <a:lstStyle>
-            <a:lvl1pPr>
-              <a:defRPr sz="1000">
-                <a:solidFill>
-                  <a:schemeClr val="accent5"/>
-                </a:solidFill>
-              </a:defRPr>
-            </a:lvl1pPr>
-          </a:lstStyle>
-          <a:p>
-            <a:pPr algn="l"/>
-            <a:fld id="{F7021451-1387-4CA6-816F-3879F97B5CBC}" type="slidenum">
-              <a:rPr lang="en-US" b="0"/>
-              <a:t>11</a:t>
-            </a:fld>
-            <a:endParaRPr lang="en-US"/>
-          </a:p>
-        </p:txBody>
-      </p:sp>
-    </p:spTree>
-  </p:cSld>
-  <p:clrMapOvr>
-    <a:masterClrMapping/>
-  </p:clrMapOvr>
-  <p:timing>
-    <p:tnLst>
-      <p:par>
-        <p:cTn id="1" dur="indefinite" restart="never" nodeType="tmRoot"/>
-      </p:par>
-    </p:tnLst>
-  </p:timing>
-</p:sld>
-</file>
-
-<file path=ppt/slides/slide12.xml><?xml version="1.0" encoding="utf-8"?>
-<p:sld xmlns:a="http://schemas.openxmlformats.org/drawingml/2006/main" xmlns:r="http://schemas.openxmlformats.org/officeDocument/2006/relationships" xmlns:p="http://schemas.openxmlformats.org/presentationml/2006/main">
-  <p:cSld>
-    <p:spTree>
-      <p:nvGrpSpPr>
-        <p:cNvPr id="1" name=""/>
-        <p:cNvGrpSpPr/>
-        <p:nvPr/>
-      </p:nvGrpSpPr>
-      <p:grpSpPr>
-        <a:xfrm>
-          <a:off x="0" y="0"/>
-          <a:ext cx="0" cy="0"/>
-          <a:chOff x="0" y="0"/>
-          <a:chExt cx="0" cy="0"/>
-        </a:xfrm>
-      </p:grpSpPr>
-    </p:spTree>
-  </p:cSld>
-  <p:clrMapOvr>
-    <a:masterClrMapping/>
-  </p:clrMapOvr>
-  <p:timing>
-    <p:tnLst>
-      <p:par>
-        <p:cTn id="1" dur="indefinite" restart="never" nodeType="tmRoot"/>
-      </p:par>
-    </p:tnLst>
-  </p:timing>
-</p:sld>
-</file>
-
-<file path=ppt/slides/slide13.xml><?xml version="1.0" encoding="utf-8"?>
 <p:sld xmlns:a="http://schemas.openxmlformats.org/drawingml/2006/main" xmlns:r="http://schemas.openxmlformats.org/officeDocument/2006/relationships" xmlns:p="http://schemas.openxmlformats.org/presentationml/2006/main">
   <p:cSld name="Slide 11">
     <p:spTree>
@@ -5438,67 +4916,15 @@
           </a:p>
         </p:txBody>
       </p:sp>
-      <p:sp>
-        <p:nvSpPr>
-          <p:cNvPr id="25" name="Slide Number Placeholder 0"/>
-          <p:cNvSpPr>
-            <a:spLocks noGrp="1"/>
-          </p:cNvSpPr>
-          <p:nvPr>
-            <p:ph type="sldNum" sz="quarter" idx="4294967295"/>
-          </p:nvPr>
-        </p:nvSpPr>
-        <p:spPr>
-          <a:xfrm>
-            <a:off x="8229600" y="4754880"/>
-            <a:ext cx="365760" cy="274320"/>
-          </a:xfrm>
-          <a:prstGeom prst="rect">
-            <a:avLst/>
-          </a:prstGeom>
-          <a:extLst>
-            <a:ext uri="{C572A759-6A51-4108-AA02-DFA0A04FC94B}">
-              <ma14:wrappingTextBoxFlag xmlns="" xmlns:ma14="http://schemas.microsoft.com/office/mac/drawingml/2011/main" val="0"/>
-            </a:ext>
-          </a:extLst>
-        </p:spPr>
-        <p:txBody>
-          <a:bodyPr/>
-          <a:lstStyle>
-            <a:lvl1pPr>
-              <a:defRPr sz="1000">
-                <a:solidFill>
-                  <a:schemeClr val="accent5"/>
-                </a:solidFill>
-              </a:defRPr>
-            </a:lvl1pPr>
-          </a:lstStyle>
-          <a:p>
-            <a:pPr algn="l"/>
-            <a:fld id="{F7021451-1387-4CA6-816F-3879F97B5CBC}" type="slidenum">
-              <a:rPr lang="en-US" b="0"/>
-              <a:t>13</a:t>
-            </a:fld>
-            <a:endParaRPr lang="en-US"/>
-          </a:p>
-        </p:txBody>
-      </p:sp>
     </p:spTree>
   </p:cSld>
   <p:clrMapOvr>
     <a:masterClrMapping/>
   </p:clrMapOvr>
-  <p:timing>
-    <p:tnLst>
-      <p:par>
-        <p:cTn id="1" dur="indefinite" restart="never" nodeType="tmRoot"/>
-      </p:par>
-    </p:tnLst>
-  </p:timing>
 </p:sld>
 </file>
 
-<file path=ppt/slides/slide14.xml><?xml version="1.0" encoding="utf-8"?>
+<file path=ppt/slides/slide11.xml><?xml version="1.0" encoding="utf-8"?>
 <p:sld xmlns:a="http://schemas.openxmlformats.org/drawingml/2006/main" xmlns:r="http://schemas.openxmlformats.org/officeDocument/2006/relationships" xmlns:p="http://schemas.openxmlformats.org/presentationml/2006/main">
   <p:cSld name="Slide 12">
     <p:spTree>
@@ -6244,67 +5670,411 @@
           </a:p>
         </p:txBody>
       </p:sp>
-      <p:sp>
-        <p:nvSpPr>
-          <p:cNvPr id="25" name="Slide Number Placeholder 0"/>
-          <p:cNvSpPr>
-            <a:spLocks noGrp="1"/>
-          </p:cNvSpPr>
-          <p:nvPr>
-            <p:ph type="sldNum" sz="quarter" idx="4294967295"/>
-          </p:nvPr>
-        </p:nvSpPr>
-        <p:spPr>
-          <a:xfrm>
-            <a:off x="8229600" y="4754880"/>
-            <a:ext cx="365760" cy="274320"/>
-          </a:xfrm>
-          <a:prstGeom prst="rect">
-            <a:avLst/>
-          </a:prstGeom>
-          <a:extLst>
-            <a:ext uri="{C572A759-6A51-4108-AA02-DFA0A04FC94B}">
-              <ma14:wrappingTextBoxFlag xmlns="" xmlns:ma14="http://schemas.microsoft.com/office/mac/drawingml/2011/main" val="0"/>
-            </a:ext>
-          </a:extLst>
-        </p:spPr>
-        <p:txBody>
-          <a:bodyPr/>
-          <a:lstStyle>
-            <a:lvl1pPr>
-              <a:defRPr sz="1000">
-                <a:solidFill>
-                  <a:schemeClr val="accent5"/>
-                </a:solidFill>
-              </a:defRPr>
-            </a:lvl1pPr>
-          </a:lstStyle>
-          <a:p>
-            <a:pPr algn="l"/>
-            <a:fld id="{F7021451-1387-4CA6-816F-3879F97B5CBC}" type="slidenum">
-              <a:rPr lang="en-US" b="0"/>
-              <a:t>14</a:t>
-            </a:fld>
-            <a:endParaRPr lang="en-US"/>
-          </a:p>
-        </p:txBody>
-      </p:sp>
     </p:spTree>
   </p:cSld>
   <p:clrMapOvr>
     <a:masterClrMapping/>
   </p:clrMapOvr>
-  <p:timing>
-    <p:tnLst>
-      <p:par>
-        <p:cTn id="1" dur="indefinite" restart="never" nodeType="tmRoot"/>
-      </p:par>
-    </p:tnLst>
-  </p:timing>
 </p:sld>
 </file>
 
-<file path=ppt/slides/slide15.xml><?xml version="1.0" encoding="utf-8"?>
+<file path=ppt/slides/slide12.xml><?xml version="1.0" encoding="utf-8"?>
+<p:sld xmlns:a="http://schemas.openxmlformats.org/drawingml/2006/main" xmlns:r="http://schemas.openxmlformats.org/officeDocument/2006/relationships" xmlns:p="http://schemas.openxmlformats.org/presentationml/2006/main">
+  <p:cSld>
+    <p:spTree>
+      <p:nvGrpSpPr>
+        <p:cNvPr id="1" name="">
+          <a:extLst>
+            <a:ext uri="{FF2B5EF4-FFF2-40B4-BE49-F238E27FC236}">
+              <a16:creationId xmlns:a16="http://schemas.microsoft.com/office/drawing/2014/main" id="{56888163-D584-666B-3707-539E30FB0666}"/>
+            </a:ext>
+          </a:extLst>
+        </p:cNvPr>
+        <p:cNvGrpSpPr/>
+        <p:nvPr/>
+      </p:nvGrpSpPr>
+      <p:grpSpPr>
+        <a:xfrm>
+          <a:off x="0" y="0"/>
+          <a:ext cx="0" cy="0"/>
+          <a:chOff x="0" y="0"/>
+          <a:chExt cx="0" cy="0"/>
+        </a:xfrm>
+      </p:grpSpPr>
+      <p:sp>
+        <p:nvSpPr>
+          <p:cNvPr id="21" name="Rounded Rectangle 4">
+            <a:extLst>
+              <a:ext uri="{FF2B5EF4-FFF2-40B4-BE49-F238E27FC236}">
+                <a16:creationId xmlns:a16="http://schemas.microsoft.com/office/drawing/2014/main" id="{A9EC442A-6CFC-A090-EE53-32BF4E47E4A8}"/>
+              </a:ext>
+            </a:extLst>
+          </p:cNvPr>
+          <p:cNvSpPr/>
+          <p:nvPr/>
+        </p:nvSpPr>
+        <p:spPr>
+          <a:xfrm>
+            <a:off x="209454" y="1178343"/>
+            <a:ext cx="8591646" cy="3234398"/>
+          </a:xfrm>
+          <a:prstGeom prst="roundRect">
+            <a:avLst/>
+          </a:prstGeom>
+          <a:solidFill>
+            <a:srgbClr val="F7F9FC"/>
+          </a:solidFill>
+          <a:ln>
+            <a:solidFill>
+              <a:srgbClr val="D7E0EA"/>
+            </a:solidFill>
+          </a:ln>
+        </p:spPr>
+        <p:style>
+          <a:lnRef idx="1">
+            <a:schemeClr val="accent1"/>
+          </a:lnRef>
+          <a:fillRef idx="3">
+            <a:schemeClr val="accent1"/>
+          </a:fillRef>
+          <a:effectRef idx="2">
+            <a:schemeClr val="accent1"/>
+          </a:effectRef>
+          <a:fontRef idx="minor">
+            <a:schemeClr val="lt1"/>
+          </a:fontRef>
+        </p:style>
+        <p:txBody>
+          <a:bodyPr rtlCol="0" anchor="ctr"/>
+          <a:lstStyle/>
+          <a:p>
+            <a:pPr algn="ctr"/>
+            <a:endParaRPr/>
+          </a:p>
+        </p:txBody>
+      </p:sp>
+      <p:sp>
+        <p:nvSpPr>
+          <p:cNvPr id="2" name="Text 0">
+            <a:extLst>
+              <a:ext uri="{FF2B5EF4-FFF2-40B4-BE49-F238E27FC236}">
+                <a16:creationId xmlns:a16="http://schemas.microsoft.com/office/drawing/2014/main" id="{32154F4B-74F1-BEC8-BB94-A4450142FFCF}"/>
+              </a:ext>
+            </a:extLst>
+          </p:cNvPr>
+          <p:cNvSpPr>
+            <a:spLocks noGrp="1"/>
+          </p:cNvSpPr>
+          <p:nvPr>
+            <p:ph type="title" idx="100" hasCustomPrompt="1"/>
+          </p:nvPr>
+        </p:nvSpPr>
+        <p:spPr>
+          <a:xfrm>
+            <a:off x="548640" y="274320"/>
+            <a:ext cx="8046720" cy="731520"/>
+          </a:xfrm>
+          <a:prstGeom prst="rect">
+            <a:avLst/>
+          </a:prstGeom>
+          <a:noFill/>
+          <a:ln/>
+        </p:spPr>
+        <p:txBody>
+          <a:bodyPr wrap="square" lIns="0" tIns="0" rIns="0" bIns="0" rtlCol="0" anchor="ctr"/>
+          <a:lstStyle/>
+          <a:p>
+            <a:r>
+              <a:rPr lang="en-US" sz="2800" dirty="0"/>
+              <a:t>Our novelty &amp; what the results actually show</a:t>
+            </a:r>
+          </a:p>
+        </p:txBody>
+      </p:sp>
+      <p:sp>
+        <p:nvSpPr>
+          <p:cNvPr id="11" name="TextBox 10">
+            <a:extLst>
+              <a:ext uri="{FF2B5EF4-FFF2-40B4-BE49-F238E27FC236}">
+                <a16:creationId xmlns:a16="http://schemas.microsoft.com/office/drawing/2014/main" id="{95CC1514-033E-E89F-CB65-AE9D3DE0CCA6}"/>
+              </a:ext>
+            </a:extLst>
+          </p:cNvPr>
+          <p:cNvSpPr txBox="1"/>
+          <p:nvPr/>
+        </p:nvSpPr>
+        <p:spPr>
+          <a:xfrm>
+            <a:off x="557867" y="1378128"/>
+            <a:ext cx="3147015" cy="400110"/>
+          </a:xfrm>
+          <a:prstGeom prst="rect">
+            <a:avLst/>
+          </a:prstGeom>
+          <a:noFill/>
+        </p:spPr>
+        <p:txBody>
+          <a:bodyPr wrap="none">
+            <a:spAutoFit/>
+          </a:bodyPr>
+          <a:lstStyle/>
+          <a:p>
+            <a:pPr>
+              <a:defRPr sz="1800" b="1">
+                <a:solidFill>
+                  <a:srgbClr val="193052"/>
+                </a:solidFill>
+              </a:defRPr>
+            </a:pPr>
+            <a:r>
+              <a:rPr dirty="0"/>
+              <a:t>What is new in our </a:t>
+            </a:r>
+            <a:r>
+              <a:rPr sz="2000" dirty="0"/>
+              <a:t>approach</a:t>
+            </a:r>
+            <a:r>
+              <a:rPr dirty="0"/>
+              <a:t>?</a:t>
+            </a:r>
+          </a:p>
+        </p:txBody>
+      </p:sp>
+      <p:sp>
+        <p:nvSpPr>
+          <p:cNvPr id="13" name="TextBox 12">
+            <a:extLst>
+              <a:ext uri="{FF2B5EF4-FFF2-40B4-BE49-F238E27FC236}">
+                <a16:creationId xmlns:a16="http://schemas.microsoft.com/office/drawing/2014/main" id="{5AD22475-31C2-C529-810C-2B4CADBABFB4}"/>
+              </a:ext>
+            </a:extLst>
+          </p:cNvPr>
+          <p:cNvSpPr txBox="1"/>
+          <p:nvPr/>
+        </p:nvSpPr>
+        <p:spPr>
+          <a:xfrm>
+            <a:off x="555155" y="1768513"/>
+            <a:ext cx="8064316" cy="553998"/>
+          </a:xfrm>
+          <a:prstGeom prst="rect">
+            <a:avLst/>
+          </a:prstGeom>
+          <a:noFill/>
+        </p:spPr>
+        <p:txBody>
+          <a:bodyPr wrap="square">
+            <a:spAutoFit/>
+          </a:bodyPr>
+          <a:lstStyle/>
+          <a:p>
+            <a:pPr>
+              <a:defRPr sz="1200" b="1">
+                <a:solidFill>
+                  <a:srgbClr val="3769A0"/>
+                </a:solidFill>
+              </a:defRPr>
+            </a:pPr>
+            <a:r>
+              <a:rPr sz="1600" dirty="0"/>
+              <a:t>Feature engineering:</a:t>
+            </a:r>
+          </a:p>
+          <a:p>
+            <a:pPr>
+              <a:defRPr sz="1050">
+                <a:solidFill>
+                  <a:srgbClr val="2D343C"/>
+                </a:solidFill>
+              </a:defRPr>
+            </a:pPr>
+            <a:r>
+              <a:rPr sz="1400" dirty="0"/>
+              <a:t>three audio-feature ratios plus metadata such as popularity, duration and release year.</a:t>
+            </a:r>
+          </a:p>
+        </p:txBody>
+      </p:sp>
+      <p:sp>
+        <p:nvSpPr>
+          <p:cNvPr id="15" name="TextBox 14">
+            <a:extLst>
+              <a:ext uri="{FF2B5EF4-FFF2-40B4-BE49-F238E27FC236}">
+                <a16:creationId xmlns:a16="http://schemas.microsoft.com/office/drawing/2014/main" id="{00F4FF10-90DA-C6DF-69BD-BCF611925E27}"/>
+              </a:ext>
+            </a:extLst>
+          </p:cNvPr>
+          <p:cNvSpPr txBox="1"/>
+          <p:nvPr/>
+        </p:nvSpPr>
+        <p:spPr>
+          <a:xfrm>
+            <a:off x="531044" y="2354491"/>
+            <a:ext cx="8064316" cy="553998"/>
+          </a:xfrm>
+          <a:prstGeom prst="rect">
+            <a:avLst/>
+          </a:prstGeom>
+          <a:noFill/>
+        </p:spPr>
+        <p:txBody>
+          <a:bodyPr wrap="square">
+            <a:spAutoFit/>
+          </a:bodyPr>
+          <a:lstStyle/>
+          <a:p>
+            <a:pPr>
+              <a:defRPr sz="1200" b="1">
+                <a:solidFill>
+                  <a:srgbClr val="3769A0"/>
+                </a:solidFill>
+              </a:defRPr>
+            </a:pPr>
+            <a:r>
+              <a:rPr sz="1600" dirty="0"/>
+              <a:t>Model exploration:</a:t>
+            </a:r>
+          </a:p>
+          <a:p>
+            <a:pPr>
+              <a:defRPr sz="1050">
+                <a:solidFill>
+                  <a:srgbClr val="2D343C"/>
+                </a:solidFill>
+              </a:defRPr>
+            </a:pPr>
+            <a:r>
+              <a:rPr sz="1400" dirty="0"/>
+              <a:t>tuned tree ensembles compared with the paper’s Perceptron/SVM/NN baselines; Random Forest led our CV.</a:t>
+            </a:r>
+          </a:p>
+        </p:txBody>
+      </p:sp>
+      <p:sp>
+        <p:nvSpPr>
+          <p:cNvPr id="17" name="TextBox 16">
+            <a:extLst>
+              <a:ext uri="{FF2B5EF4-FFF2-40B4-BE49-F238E27FC236}">
+                <a16:creationId xmlns:a16="http://schemas.microsoft.com/office/drawing/2014/main" id="{0121F7CF-C9DF-76C2-6C32-E52BEFF8FB1A}"/>
+              </a:ext>
+            </a:extLst>
+          </p:cNvPr>
+          <p:cNvSpPr txBox="1"/>
+          <p:nvPr/>
+        </p:nvSpPr>
+        <p:spPr>
+          <a:xfrm>
+            <a:off x="540555" y="2953369"/>
+            <a:ext cx="8064316" cy="553998"/>
+          </a:xfrm>
+          <a:prstGeom prst="rect">
+            <a:avLst/>
+          </a:prstGeom>
+          <a:noFill/>
+        </p:spPr>
+        <p:txBody>
+          <a:bodyPr wrap="square">
+            <a:spAutoFit/>
+          </a:bodyPr>
+          <a:lstStyle/>
+          <a:p>
+            <a:pPr>
+              <a:defRPr sz="1200" b="1">
+                <a:solidFill>
+                  <a:srgbClr val="3769A0"/>
+                </a:solidFill>
+              </a:defRPr>
+            </a:pPr>
+            <a:r>
+              <a:rPr sz="1600" dirty="0"/>
+              <a:t>Leakage-aware evaluation:</a:t>
+            </a:r>
+          </a:p>
+          <a:p>
+            <a:pPr>
+              <a:defRPr sz="1050">
+                <a:solidFill>
+                  <a:srgbClr val="2D343C"/>
+                </a:solidFill>
+              </a:defRPr>
+            </a:pPr>
+            <a:r>
+              <a:rPr sz="1400" dirty="0"/>
+              <a:t>preprocessing, feature selection and tuning are kept within training/CV pipelines; test set reported once.</a:t>
+            </a:r>
+          </a:p>
+        </p:txBody>
+      </p:sp>
+      <p:sp>
+        <p:nvSpPr>
+          <p:cNvPr id="19" name="TextBox 18">
+            <a:extLst>
+              <a:ext uri="{FF2B5EF4-FFF2-40B4-BE49-F238E27FC236}">
+                <a16:creationId xmlns:a16="http://schemas.microsoft.com/office/drawing/2014/main" id="{C3DA1936-ADEA-9C1D-D37B-966E0C18BB89}"/>
+              </a:ext>
+            </a:extLst>
+          </p:cNvPr>
+          <p:cNvSpPr txBox="1"/>
+          <p:nvPr/>
+        </p:nvSpPr>
+        <p:spPr>
+          <a:xfrm>
+            <a:off x="524442" y="3589124"/>
+            <a:ext cx="8064316" cy="553998"/>
+          </a:xfrm>
+          <a:prstGeom prst="rect">
+            <a:avLst/>
+          </a:prstGeom>
+          <a:noFill/>
+        </p:spPr>
+        <p:txBody>
+          <a:bodyPr wrap="square">
+            <a:spAutoFit/>
+          </a:bodyPr>
+          <a:lstStyle/>
+          <a:p>
+            <a:pPr>
+              <a:defRPr sz="1200" b="1">
+                <a:solidFill>
+                  <a:srgbClr val="3769A0"/>
+                </a:solidFill>
+              </a:defRPr>
+            </a:pPr>
+            <a:r>
+              <a:rPr sz="1600" dirty="0"/>
+              <a:t>Confidence-aware output:</a:t>
+            </a:r>
+          </a:p>
+          <a:p>
+            <a:pPr>
+              <a:defRPr sz="1050">
+                <a:solidFill>
+                  <a:srgbClr val="2D343C"/>
+                </a:solidFill>
+              </a:defRPr>
+            </a:pPr>
+            <a:r>
+              <a:rPr lang="en-US" sz="1400" dirty="0"/>
+              <a:t>low-confidence predictions trigger a new-playlist suggestion instead of forcing a weak label.</a:t>
+            </a:r>
+          </a:p>
+        </p:txBody>
+      </p:sp>
+    </p:spTree>
+    <p:extLst>
+      <p:ext uri="{BB962C8B-B14F-4D97-AF65-F5344CB8AC3E}">
+        <p14:creationId xmlns:p14="http://schemas.microsoft.com/office/powerpoint/2010/main" val="113629572"/>
+      </p:ext>
+    </p:extLst>
+  </p:cSld>
+  <p:clrMapOvr>
+    <a:masterClrMapping/>
+  </p:clrMapOvr>
+</p:sld>
+</file>
+
+<file path=ppt/slides/slide13.xml><?xml version="1.0" encoding="utf-8"?>
 <p:sld xmlns:a="http://schemas.openxmlformats.org/drawingml/2006/main" xmlns:r="http://schemas.openxmlformats.org/officeDocument/2006/relationships" xmlns:p="http://schemas.openxmlformats.org/presentationml/2006/main">
   <p:cSld name="Slide 13">
     <p:spTree>
@@ -6586,8 +6356,160 @@
               </a:rPr>
               <a:t>Abstain rule, saved model, demo (15, 16)</a:t>
             </a:r>
-            <a:endParaRPr lang="en-US" sz="1300" dirty="0"/>
-          </a:p>
+          </a:p>
+          <a:p>
+            <a:pPr marL="342900" indent="-342900">
+              <a:spcAft>
+                <a:spcPts val="600"/>
+              </a:spcAft>
+              <a:buSzPct val="100000"/>
+              <a:buFontTx/>
+              <a:buChar char="•"/>
+            </a:pPr>
+            <a:r>
+              <a:rPr lang="en-US" sz="1300" dirty="0"/>
+              <a:t>Segmentation study (12)</a:t>
+            </a:r>
+          </a:p>
+        </p:txBody>
+      </p:sp>
+      <p:sp>
+        <p:nvSpPr>
+          <p:cNvPr id="8" name="team_card_1"/>
+          <p:cNvSpPr/>
+          <p:nvPr/>
+        </p:nvSpPr>
+        <p:spPr>
+          <a:xfrm>
+            <a:off x="4663440" y="1234440"/>
+            <a:ext cx="3931920" cy="2834640"/>
+          </a:xfrm>
+          <a:prstGeom prst="roundRect">
+            <a:avLst>
+              <a:gd name="adj" fmla="val 3871"/>
+            </a:avLst>
+          </a:prstGeom>
+          <a:solidFill>
+            <a:schemeClr val="bg2"/>
+          </a:solidFill>
+          <a:ln/>
+        </p:spPr>
+      </p:sp>
+      <p:sp>
+        <p:nvSpPr>
+          <p:cNvPr id="9" name="team_dot_1"/>
+          <p:cNvSpPr/>
+          <p:nvPr/>
+        </p:nvSpPr>
+        <p:spPr>
+          <a:xfrm>
+            <a:off x="4892040" y="1417320"/>
+            <a:ext cx="457200" cy="457200"/>
+          </a:xfrm>
+          <a:prstGeom prst="ellipse">
+            <a:avLst/>
+          </a:prstGeom>
+          <a:solidFill>
+            <a:schemeClr val="accent2"/>
+          </a:solidFill>
+          <a:ln/>
+        </p:spPr>
+      </p:sp>
+      <p:sp>
+        <p:nvSpPr>
+          <p:cNvPr id="10" name="team_n_1"/>
+          <p:cNvSpPr txBox="1"/>
+          <p:nvPr/>
+        </p:nvSpPr>
+        <p:spPr>
+          <a:xfrm>
+            <a:off x="5532120" y="1389888"/>
+            <a:ext cx="2926080" cy="320040"/>
+          </a:xfrm>
+          <a:prstGeom prst="rect">
+            <a:avLst/>
+          </a:prstGeom>
+          <a:noFill/>
+          <a:ln/>
+        </p:spPr>
+        <p:txBody>
+          <a:bodyPr wrap="square" lIns="0" tIns="0" rIns="0" bIns="0" rtlCol="0" anchor="t"/>
+          <a:lstStyle/>
+          <a:p>
+            <a:pPr marL="0" indent="0">
+              <a:buNone/>
+            </a:pPr>
+            <a:r>
+              <a:rPr lang="en-US" sz="1800" b="1" dirty="0">
+                <a:solidFill>
+                  <a:schemeClr val="tx1"/>
+                </a:solidFill>
+                <a:latin typeface="Cambria" pitchFamily="34" charset="0"/>
+                <a:ea typeface="Cambria" pitchFamily="34" charset="-122"/>
+                <a:cs typeface="Cambria" pitchFamily="34" charset="-120"/>
+              </a:rPr>
+              <a:t>Sai Manogna B V</a:t>
+            </a:r>
+            <a:endParaRPr lang="en-US" sz="1800" dirty="0"/>
+          </a:p>
+        </p:txBody>
+      </p:sp>
+      <p:sp>
+        <p:nvSpPr>
+          <p:cNvPr id="11" name="team_s_1"/>
+          <p:cNvSpPr txBox="1"/>
+          <p:nvPr/>
+        </p:nvSpPr>
+        <p:spPr>
+          <a:xfrm>
+            <a:off x="5532120" y="1709928"/>
+            <a:ext cx="2926080" cy="228600"/>
+          </a:xfrm>
+          <a:prstGeom prst="rect">
+            <a:avLst/>
+          </a:prstGeom>
+          <a:noFill/>
+          <a:ln/>
+        </p:spPr>
+        <p:txBody>
+          <a:bodyPr wrap="square" lIns="0" tIns="0" rIns="0" bIns="0" rtlCol="0" anchor="t"/>
+          <a:lstStyle/>
+          <a:p>
+            <a:pPr marL="0" indent="0">
+              <a:buNone/>
+            </a:pPr>
+            <a:r>
+              <a:rPr lang="en-US" sz="1200" dirty="0">
+                <a:solidFill>
+                  <a:schemeClr val="accent5"/>
+                </a:solidFill>
+              </a:rPr>
+              <a:t>PES1UG24CS399</a:t>
+            </a:r>
+            <a:endParaRPr lang="en-US" sz="1200" dirty="0"/>
+          </a:p>
+        </p:txBody>
+      </p:sp>
+      <p:sp>
+        <p:nvSpPr>
+          <p:cNvPr id="12" name="team_b_1"/>
+          <p:cNvSpPr txBox="1"/>
+          <p:nvPr/>
+        </p:nvSpPr>
+        <p:spPr>
+          <a:xfrm>
+            <a:off x="4937760" y="2148840"/>
+            <a:ext cx="3474720" cy="1874520"/>
+          </a:xfrm>
+          <a:prstGeom prst="rect">
+            <a:avLst/>
+          </a:prstGeom>
+          <a:noFill/>
+          <a:ln/>
+        </p:spPr>
+        <p:txBody>
+          <a:bodyPr wrap="square" lIns="0" tIns="0" rIns="0" bIns="0" rtlCol="0" anchor="t"/>
+          <a:lstStyle/>
           <a:p>
             <a:pPr marL="342900" indent="-342900">
               <a:spcAft>
@@ -6602,149 +6524,10 @@
                   <a:schemeClr val="tx1"/>
                 </a:solidFill>
               </a:rPr>
-              <a:t>Streamlit app, README</a:t>
+              <a:t>Dataset, EDA, cleaning, preprocessing, features (1 to 6)</a:t>
             </a:r>
             <a:endParaRPr lang="en-US" sz="1300" dirty="0"/>
           </a:p>
-        </p:txBody>
-      </p:sp>
-      <p:sp>
-        <p:nvSpPr>
-          <p:cNvPr id="8" name="team_card_1"/>
-          <p:cNvSpPr/>
-          <p:nvPr/>
-        </p:nvSpPr>
-        <p:spPr>
-          <a:xfrm>
-            <a:off x="4663440" y="1234440"/>
-            <a:ext cx="3931920" cy="2834640"/>
-          </a:xfrm>
-          <a:prstGeom prst="roundRect">
-            <a:avLst>
-              <a:gd name="adj" fmla="val 3871"/>
-            </a:avLst>
-          </a:prstGeom>
-          <a:solidFill>
-            <a:schemeClr val="bg2"/>
-          </a:solidFill>
-          <a:ln/>
-        </p:spPr>
-      </p:sp>
-      <p:sp>
-        <p:nvSpPr>
-          <p:cNvPr id="9" name="team_dot_1"/>
-          <p:cNvSpPr/>
-          <p:nvPr/>
-        </p:nvSpPr>
-        <p:spPr>
-          <a:xfrm>
-            <a:off x="4892040" y="1417320"/>
-            <a:ext cx="457200" cy="457200"/>
-          </a:xfrm>
-          <a:prstGeom prst="ellipse">
-            <a:avLst/>
-          </a:prstGeom>
-          <a:solidFill>
-            <a:schemeClr val="accent2"/>
-          </a:solidFill>
-          <a:ln/>
-        </p:spPr>
-      </p:sp>
-      <p:sp>
-        <p:nvSpPr>
-          <p:cNvPr id="10" name="team_n_1"/>
-          <p:cNvSpPr txBox="1"/>
-          <p:nvPr/>
-        </p:nvSpPr>
-        <p:spPr>
-          <a:xfrm>
-            <a:off x="5532120" y="1389888"/>
-            <a:ext cx="2926080" cy="320040"/>
-          </a:xfrm>
-          <a:prstGeom prst="rect">
-            <a:avLst/>
-          </a:prstGeom>
-          <a:noFill/>
-          <a:ln/>
-        </p:spPr>
-        <p:txBody>
-          <a:bodyPr wrap="square" lIns="0" tIns="0" rIns="0" bIns="0" rtlCol="0" anchor="t"/>
-          <a:lstStyle/>
-          <a:p>
-            <a:pPr marL="0" indent="0">
-              <a:buNone/>
-            </a:pPr>
-            <a:r>
-              <a:rPr lang="en-US" sz="1800" b="1" dirty="0">
-                <a:solidFill>
-                  <a:schemeClr val="tx1"/>
-                </a:solidFill>
-                <a:latin typeface="Cambria" pitchFamily="34" charset="0"/>
-                <a:ea typeface="Cambria" pitchFamily="34" charset="-122"/>
-                <a:cs typeface="Cambria" pitchFamily="34" charset="-120"/>
-              </a:rPr>
-              <a:t>Sai Manogna B V</a:t>
-            </a:r>
-            <a:endParaRPr lang="en-US" sz="1800" dirty="0"/>
-          </a:p>
-        </p:txBody>
-      </p:sp>
-      <p:sp>
-        <p:nvSpPr>
-          <p:cNvPr id="11" name="team_s_1"/>
-          <p:cNvSpPr txBox="1"/>
-          <p:nvPr/>
-        </p:nvSpPr>
-        <p:spPr>
-          <a:xfrm>
-            <a:off x="5532120" y="1709928"/>
-            <a:ext cx="2926080" cy="228600"/>
-          </a:xfrm>
-          <a:prstGeom prst="rect">
-            <a:avLst/>
-          </a:prstGeom>
-          <a:noFill/>
-          <a:ln/>
-        </p:spPr>
-        <p:txBody>
-          <a:bodyPr wrap="square" lIns="0" tIns="0" rIns="0" bIns="0" rtlCol="0" anchor="t"/>
-          <a:lstStyle/>
-          <a:p>
-            <a:pPr marL="0" indent="0">
-              <a:buNone/>
-            </a:pPr>
-            <a:r>
-              <a:rPr lang="en-US" sz="1200" dirty="0">
-                <a:solidFill>
-                  <a:schemeClr val="accent5"/>
-                </a:solidFill>
-              </a:rPr>
-              <a:t>PES1UG24CS399</a:t>
-            </a:r>
-            <a:endParaRPr lang="en-US" sz="1200" dirty="0"/>
-          </a:p>
-        </p:txBody>
-      </p:sp>
-      <p:sp>
-        <p:nvSpPr>
-          <p:cNvPr id="12" name="team_b_1"/>
-          <p:cNvSpPr txBox="1"/>
-          <p:nvPr/>
-        </p:nvSpPr>
-        <p:spPr>
-          <a:xfrm>
-            <a:off x="4937760" y="2148840"/>
-            <a:ext cx="3474720" cy="1874520"/>
-          </a:xfrm>
-          <a:prstGeom prst="rect">
-            <a:avLst/>
-          </a:prstGeom>
-          <a:noFill/>
-          <a:ln/>
-        </p:spPr>
-        <p:txBody>
-          <a:bodyPr wrap="square" lIns="0" tIns="0" rIns="0" bIns="0" rtlCol="0" anchor="t"/>
-          <a:lstStyle/>
           <a:p>
             <a:pPr marL="342900" indent="-342900">
               <a:spcAft>
@@ -6759,7 +6542,7 @@
                   <a:schemeClr val="tx1"/>
                 </a:solidFill>
               </a:rPr>
-              <a:t>Dataset, EDA, cleaning, preprocessing, features (1 to 6)</a:t>
+              <a:t>Baseline replication (8)</a:t>
             </a:r>
             <a:endParaRPr lang="en-US" sz="1300" dirty="0"/>
           </a:p>
@@ -6777,7 +6560,7 @@
                   <a:schemeClr val="tx1"/>
                 </a:solidFill>
               </a:rPr>
-              <a:t>Baseline replication (8)</a:t>
+              <a:t>Repeated CV (10), feature selection (11)</a:t>
             </a:r>
             <a:endParaRPr lang="en-US" sz="1300" dirty="0"/>
           </a:p>
@@ -6795,42 +6578,6 @@
                   <a:schemeClr val="tx1"/>
                 </a:solidFill>
               </a:rPr>
-              <a:t>Repeated CV (10), feature selection (11)</a:t>
-            </a:r>
-            <a:endParaRPr lang="en-US" sz="1300" dirty="0"/>
-          </a:p>
-          <a:p>
-            <a:pPr marL="342900" indent="-342900">
-              <a:spcAft>
-                <a:spcPts val="600"/>
-              </a:spcAft>
-              <a:buSzPct val="100000"/>
-              <a:buChar char="•"/>
-            </a:pPr>
-            <a:r>
-              <a:rPr lang="en-US" sz="1300" dirty="0">
-                <a:solidFill>
-                  <a:schemeClr val="tx1"/>
-                </a:solidFill>
-              </a:rPr>
-              <a:t>Segmentation study (12)</a:t>
-            </a:r>
-            <a:endParaRPr lang="en-US" sz="1300" dirty="0"/>
-          </a:p>
-          <a:p>
-            <a:pPr marL="342900" indent="-342900">
-              <a:spcAft>
-                <a:spcPts val="600"/>
-              </a:spcAft>
-              <a:buSzPct val="100000"/>
-              <a:buChar char="•"/>
-            </a:pPr>
-            <a:r>
-              <a:rPr lang="en-US" sz="1300" dirty="0">
-                <a:solidFill>
-                  <a:schemeClr val="tx1"/>
-                </a:solidFill>
-              </a:rPr>
               <a:t>Error analysis and PCA (13)</a:t>
             </a:r>
             <a:endParaRPr lang="en-US" sz="1300" dirty="0"/>
@@ -6858,63 +6605,31 @@
           <a:bodyPr wrap="square" lIns="0" tIns="0" rIns="0" bIns="0" rtlCol="0" anchor="t"/>
           <a:lstStyle/>
           <a:p>
-            <a:pPr marL="0" indent="0">
-              <a:buNone/>
-            </a:pPr>
             <a:r>
               <a:rPr lang="en-US" sz="1400" dirty="0">
                 <a:solidFill>
                   <a:schemeClr val="tx1"/>
                 </a:solidFill>
               </a:rPr>
-              <a:t>Both: reading the paper, testing the code, write-up, slides, GitHub repository.</a:t>
+              <a:t>Both: reading the paper, testing the code, write-up, slides, </a:t>
+            </a:r>
+            <a:r>
+              <a:rPr lang="en-US" sz="1400" dirty="0" err="1"/>
+              <a:t>Streamlit</a:t>
+            </a:r>
+            <a:r>
+              <a:rPr lang="en-US" sz="1400" dirty="0"/>
+              <a:t> app, </a:t>
+            </a:r>
+            <a:r>
+              <a:rPr lang="en-US" sz="1400" dirty="0">
+                <a:solidFill>
+                  <a:schemeClr val="tx1"/>
+                </a:solidFill>
+              </a:rPr>
+              <a:t>GitHub repository.</a:t>
             </a:r>
             <a:endParaRPr lang="en-US" sz="1400" dirty="0"/>
-          </a:p>
-        </p:txBody>
-      </p:sp>
-      <p:sp>
-        <p:nvSpPr>
-          <p:cNvPr id="25" name="Slide Number Placeholder 0"/>
-          <p:cNvSpPr>
-            <a:spLocks noGrp="1"/>
-          </p:cNvSpPr>
-          <p:nvPr>
-            <p:ph type="sldNum" sz="quarter" idx="4294967295"/>
-          </p:nvPr>
-        </p:nvSpPr>
-        <p:spPr>
-          <a:xfrm>
-            <a:off x="8229600" y="4754880"/>
-            <a:ext cx="365760" cy="274320"/>
-          </a:xfrm>
-          <a:prstGeom prst="rect">
-            <a:avLst/>
-          </a:prstGeom>
-          <a:extLst>
-            <a:ext uri="{C572A759-6A51-4108-AA02-DFA0A04FC94B}">
-              <ma14:wrappingTextBoxFlag xmlns="" xmlns:ma14="http://schemas.microsoft.com/office/mac/drawingml/2011/main" val="0"/>
-            </a:ext>
-          </a:extLst>
-        </p:spPr>
-        <p:txBody>
-          <a:bodyPr/>
-          <a:lstStyle>
-            <a:lvl1pPr>
-              <a:defRPr sz="1000">
-                <a:solidFill>
-                  <a:schemeClr val="accent5"/>
-                </a:solidFill>
-              </a:defRPr>
-            </a:lvl1pPr>
-          </a:lstStyle>
-          <a:p>
-            <a:pPr algn="l"/>
-            <a:fld id="{F7021451-1387-4CA6-816F-3879F97B5CBC}" type="slidenum">
-              <a:rPr lang="en-US" b="0"/>
-              <a:t>15</a:t>
-            </a:fld>
-            <a:endParaRPr lang="en-US"/>
           </a:p>
         </p:txBody>
       </p:sp>
@@ -6926,7 +6641,7 @@
 </p:sld>
 </file>
 
-<file path=ppt/slides/slide16.xml><?xml version="1.0" encoding="utf-8"?>
+<file path=ppt/slides/slide14.xml><?xml version="1.0" encoding="utf-8"?>
 <p:sld xmlns:a="http://schemas.openxmlformats.org/drawingml/2006/main" xmlns:r="http://schemas.openxmlformats.org/officeDocument/2006/relationships" xmlns:p="http://schemas.openxmlformats.org/presentationml/2006/main">
   <p:cSld name="Slide 14">
     <p:spTree>
@@ -7272,51 +6987,6 @@
               <a:t>Next: genre and artist embeddings (node2vec, GloVe) as in the paper</a:t>
             </a:r>
             <a:endParaRPr lang="en-US" sz="1400" dirty="0"/>
-          </a:p>
-        </p:txBody>
-      </p:sp>
-      <p:sp>
-        <p:nvSpPr>
-          <p:cNvPr id="25" name="Slide Number Placeholder 0"/>
-          <p:cNvSpPr>
-            <a:spLocks noGrp="1"/>
-          </p:cNvSpPr>
-          <p:nvPr>
-            <p:ph type="sldNum" sz="quarter" idx="4294967295"/>
-          </p:nvPr>
-        </p:nvSpPr>
-        <p:spPr>
-          <a:xfrm>
-            <a:off x="8229600" y="4754880"/>
-            <a:ext cx="365760" cy="274320"/>
-          </a:xfrm>
-          <a:prstGeom prst="rect">
-            <a:avLst/>
-          </a:prstGeom>
-          <a:extLst>
-            <a:ext uri="{C572A759-6A51-4108-AA02-DFA0A04FC94B}">
-              <ma14:wrappingTextBoxFlag xmlns="" xmlns:ma14="http://schemas.microsoft.com/office/mac/drawingml/2011/main" val="0"/>
-            </a:ext>
-          </a:extLst>
-        </p:spPr>
-        <p:txBody>
-          <a:bodyPr/>
-          <a:lstStyle>
-            <a:lvl1pPr>
-              <a:defRPr sz="1000">
-                <a:solidFill>
-                  <a:schemeClr val="accent6"/>
-                </a:solidFill>
-              </a:defRPr>
-            </a:lvl1pPr>
-          </a:lstStyle>
-          <a:p>
-            <a:pPr algn="l"/>
-            <a:fld id="{F7021451-1387-4CA6-816F-3879F97B5CBC}" type="slidenum">
-              <a:rPr lang="en-US" b="0"/>
-              <a:t>16</a:t>
-            </a:fld>
-            <a:endParaRPr lang="en-US"/>
           </a:p>
         </p:txBody>
       </p:sp>
@@ -7942,72 +7612,26 @@
           </a:p>
         </p:txBody>
       </p:sp>
-      <p:sp>
-        <p:nvSpPr>
-          <p:cNvPr id="25" name="Slide Number Placeholder 0"/>
-          <p:cNvSpPr>
-            <a:spLocks noGrp="1"/>
-          </p:cNvSpPr>
-          <p:nvPr>
-            <p:ph type="sldNum" sz="quarter" idx="4294967295"/>
-          </p:nvPr>
-        </p:nvSpPr>
-        <p:spPr>
-          <a:xfrm>
-            <a:off x="8229600" y="4754880"/>
-            <a:ext cx="365760" cy="274320"/>
-          </a:xfrm>
-          <a:prstGeom prst="rect">
-            <a:avLst/>
-          </a:prstGeom>
-          <a:extLst>
-            <a:ext uri="{C572A759-6A51-4108-AA02-DFA0A04FC94B}">
-              <ma14:wrappingTextBoxFlag xmlns="" xmlns:ma14="http://schemas.microsoft.com/office/mac/drawingml/2011/main" val="0"/>
-            </a:ext>
-          </a:extLst>
-        </p:spPr>
-        <p:txBody>
-          <a:bodyPr/>
-          <a:lstStyle>
-            <a:lvl1pPr>
-              <a:defRPr sz="1000">
-                <a:solidFill>
-                  <a:schemeClr val="accent5"/>
-                </a:solidFill>
-              </a:defRPr>
-            </a:lvl1pPr>
-          </a:lstStyle>
-          <a:p>
-            <a:pPr algn="l"/>
-            <a:fld id="{F7021451-1387-4CA6-816F-3879F97B5CBC}" type="slidenum">
-              <a:rPr lang="en-US" b="0"/>
-              <a:t>2</a:t>
-            </a:fld>
-            <a:endParaRPr lang="en-US"/>
-          </a:p>
-        </p:txBody>
-      </p:sp>
     </p:spTree>
   </p:cSld>
   <p:clrMapOvr>
     <a:masterClrMapping/>
   </p:clrMapOvr>
-  <p:timing>
-    <p:tnLst>
-      <p:par>
-        <p:cTn id="1" dur="indefinite" restart="never" nodeType="tmRoot"/>
-      </p:par>
-    </p:tnLst>
-  </p:timing>
 </p:sld>
 </file>
 
 <file path=ppt/slides/slide3.xml><?xml version="1.0" encoding="utf-8"?>
 <p:sld xmlns:a="http://schemas.openxmlformats.org/drawingml/2006/main" xmlns:r="http://schemas.openxmlformats.org/officeDocument/2006/relationships" xmlns:p="http://schemas.openxmlformats.org/presentationml/2006/main">
-  <p:cSld name="Slide 3">
+  <p:cSld>
     <p:spTree>
       <p:nvGrpSpPr>
-        <p:cNvPr id="1" name=""/>
+        <p:cNvPr id="1" name="">
+          <a:extLst>
+            <a:ext uri="{FF2B5EF4-FFF2-40B4-BE49-F238E27FC236}">
+              <a16:creationId xmlns:a16="http://schemas.microsoft.com/office/drawing/2014/main" id="{A3F7A92C-B2EF-5889-70B2-D7AACAA69D7E}"/>
+            </a:ext>
+          </a:extLst>
+        </p:cNvPr>
         <p:cNvGrpSpPr/>
         <p:nvPr/>
       </p:nvGrpSpPr>
@@ -8021,7 +7645,13 @@
       </p:grpSpPr>
       <p:sp>
         <p:nvSpPr>
-          <p:cNvPr id="2" name="Text 0"/>
+          <p:cNvPr id="2" name="Text 0">
+            <a:extLst>
+              <a:ext uri="{FF2B5EF4-FFF2-40B4-BE49-F238E27FC236}">
+                <a16:creationId xmlns:a16="http://schemas.microsoft.com/office/drawing/2014/main" id="{A554D9A1-3E50-FB4A-BF8B-050C02793F29}"/>
+              </a:ext>
+            </a:extLst>
+          </p:cNvPr>
           <p:cNvSpPr>
             <a:spLocks noGrp="1"/>
           </p:cNvSpPr>
@@ -8044,496 +7674,37 @@
           <a:bodyPr wrap="square" lIns="0" tIns="0" rIns="0" bIns="0" rtlCol="0" anchor="ctr"/>
           <a:lstStyle/>
           <a:p>
-            <a:pPr marL="0" indent="0" algn="l">
-              <a:buNone/>
-            </a:pPr>
-            <a:r>
-              <a:rPr lang="en-US" sz="3000" b="1" dirty="0">
-                <a:solidFill>
-                  <a:schemeClr val="tx1"/>
-                </a:solidFill>
-              </a:rPr>
-              <a:t>Paper baseline vs our changes</a:t>
+            <a:r>
+              <a:rPr lang="en-US" dirty="0"/>
+              <a:t>Research paper vs our implementation</a:t>
             </a:r>
             <a:endParaRPr lang="en-US" sz="3000" dirty="0"/>
-          </a:p>
-        </p:txBody>
-      </p:sp>
-      <p:sp>
-        <p:nvSpPr>
-          <p:cNvPr id="3" name="col_0"/>
-          <p:cNvSpPr/>
-          <p:nvPr/>
-        </p:nvSpPr>
-        <p:spPr>
-          <a:xfrm>
-            <a:off x="548640" y="1280160"/>
-            <a:ext cx="3931920" cy="3017520"/>
-          </a:xfrm>
-          <a:prstGeom prst="roundRect">
-            <a:avLst>
-              <a:gd name="adj" fmla="val 3636"/>
-            </a:avLst>
-          </a:prstGeom>
-          <a:solidFill>
-            <a:schemeClr val="bg2"/>
-          </a:solidFill>
-          <a:ln/>
-        </p:spPr>
-      </p:sp>
-      <p:sp>
-        <p:nvSpPr>
-          <p:cNvPr id="4" name="colnum_0"/>
-          <p:cNvSpPr/>
-          <p:nvPr/>
-        </p:nvSpPr>
-        <p:spPr>
-          <a:xfrm>
-            <a:off x="777240" y="1481328"/>
-            <a:ext cx="457200" cy="457200"/>
-          </a:xfrm>
-          <a:prstGeom prst="ellipse">
-            <a:avLst/>
-          </a:prstGeom>
-          <a:solidFill>
-            <a:schemeClr val="accent4"/>
-          </a:solidFill>
-          <a:ln/>
-        </p:spPr>
-      </p:sp>
-      <p:sp>
-        <p:nvSpPr>
-          <p:cNvPr id="5" name="colh_0"/>
-          <p:cNvSpPr txBox="1"/>
-          <p:nvPr/>
-        </p:nvSpPr>
-        <p:spPr>
-          <a:xfrm>
-            <a:off x="1417320" y="1481328"/>
-            <a:ext cx="2926080" cy="457200"/>
-          </a:xfrm>
-          <a:prstGeom prst="rect">
-            <a:avLst/>
-          </a:prstGeom>
-          <a:noFill/>
-          <a:ln/>
-        </p:spPr>
-        <p:txBody>
-          <a:bodyPr wrap="square" lIns="0" tIns="0" rIns="0" bIns="0" rtlCol="0" anchor="ctr"/>
-          <a:lstStyle/>
-          <a:p>
-            <a:pPr marL="0" indent="0">
-              <a:buNone/>
-            </a:pPr>
-            <a:r>
-              <a:rPr lang="en-US" sz="2000" b="1" dirty="0">
-                <a:solidFill>
-                  <a:schemeClr val="tx1"/>
-                </a:solidFill>
-                <a:latin typeface="Cambria" pitchFamily="34" charset="0"/>
-                <a:ea typeface="Cambria" pitchFamily="34" charset="-122"/>
-                <a:cs typeface="Cambria" pitchFamily="34" charset="-120"/>
-              </a:rPr>
-              <a:t>Stanford paper (2018)</a:t>
-            </a:r>
-            <a:endParaRPr lang="en-US" sz="2000" dirty="0"/>
-          </a:p>
-        </p:txBody>
-      </p:sp>
-      <p:sp>
-        <p:nvSpPr>
-          <p:cNvPr id="6" name="colb_0"/>
-          <p:cNvSpPr txBox="1"/>
-          <p:nvPr/>
-        </p:nvSpPr>
-        <p:spPr>
-          <a:xfrm>
-            <a:off x="822960" y="2194560"/>
-            <a:ext cx="3429000" cy="2286000"/>
-          </a:xfrm>
-          <a:prstGeom prst="rect">
-            <a:avLst/>
-          </a:prstGeom>
-          <a:noFill/>
-          <a:ln/>
-        </p:spPr>
-        <p:txBody>
-          <a:bodyPr wrap="square" lIns="0" tIns="0" rIns="0" bIns="0" rtlCol="0" anchor="t"/>
-          <a:lstStyle/>
-          <a:p>
-            <a:pPr marL="342900" indent="-342900">
-              <a:spcAft>
-                <a:spcPts val="600"/>
-              </a:spcAft>
-              <a:buSzPct val="100000"/>
-              <a:buChar char="•"/>
-            </a:pPr>
-            <a:r>
-              <a:rPr lang="en-US" sz="1400" dirty="0">
-                <a:solidFill>
-                  <a:schemeClr val="tx1"/>
-                </a:solidFill>
-              </a:rPr>
-              <a:t>Spotify API data: 10 audio features + 2,095 genre tags</a:t>
-            </a:r>
-            <a:endParaRPr lang="en-US" sz="1400" dirty="0"/>
-          </a:p>
-          <a:p>
-            <a:pPr marL="342900" indent="-342900">
-              <a:spcAft>
-                <a:spcPts val="600"/>
-              </a:spcAft>
-              <a:buSzPct val="100000"/>
-              <a:buChar char="•"/>
-            </a:pPr>
-            <a:r>
-              <a:rPr lang="en-US" sz="1400" dirty="0">
-                <a:solidFill>
-                  <a:schemeClr val="tx1"/>
-                </a:solidFill>
-              </a:rPr>
-              <a:t>13 curated playlists, 1,044 tracks</a:t>
-            </a:r>
-            <a:endParaRPr lang="en-US" sz="1400" dirty="0"/>
-          </a:p>
-          <a:p>
-            <a:pPr marL="342900" indent="-342900">
-              <a:spcAft>
-                <a:spcPts val="600"/>
-              </a:spcAft>
-              <a:buSzPct val="100000"/>
-              <a:buChar char="•"/>
-            </a:pPr>
-            <a:r>
-              <a:rPr lang="en-US" sz="1400" dirty="0">
-                <a:solidFill>
-                  <a:schemeClr val="tx1"/>
-                </a:solidFill>
-              </a:rPr>
-              <a:t>Perceptron, SVMs, 1-hidden-layer NN</a:t>
-            </a:r>
-            <a:endParaRPr lang="en-US" sz="1400" dirty="0"/>
-          </a:p>
-          <a:p>
-            <a:pPr marL="342900" indent="-342900">
-              <a:spcAft>
-                <a:spcPts val="600"/>
-              </a:spcAft>
-              <a:buSzPct val="100000"/>
-              <a:buChar char="•"/>
-            </a:pPr>
-            <a:r>
-              <a:rPr lang="en-US" sz="1400" dirty="0">
-                <a:solidFill>
-                  <a:schemeClr val="tx1"/>
-                </a:solidFill>
-              </a:rPr>
-              <a:t>Best: NN 82% test, RBF SVM 80%</a:t>
-            </a:r>
-            <a:endParaRPr lang="en-US" sz="1400" dirty="0"/>
-          </a:p>
-        </p:txBody>
-      </p:sp>
-      <p:sp>
-        <p:nvSpPr>
-          <p:cNvPr id="7" name="col_1"/>
-          <p:cNvSpPr/>
-          <p:nvPr/>
-        </p:nvSpPr>
-        <p:spPr>
-          <a:xfrm>
-            <a:off x="4663440" y="1280160"/>
-            <a:ext cx="3931920" cy="3017520"/>
-          </a:xfrm>
-          <a:prstGeom prst="roundRect">
-            <a:avLst>
-              <a:gd name="adj" fmla="val 3636"/>
-            </a:avLst>
-          </a:prstGeom>
-          <a:solidFill>
-            <a:schemeClr val="bg2"/>
-          </a:solidFill>
-          <a:ln/>
-        </p:spPr>
-      </p:sp>
-      <p:sp>
-        <p:nvSpPr>
-          <p:cNvPr id="8" name="colnum_1"/>
-          <p:cNvSpPr/>
-          <p:nvPr/>
-        </p:nvSpPr>
-        <p:spPr>
-          <a:xfrm>
-            <a:off x="4892040" y="1481328"/>
-            <a:ext cx="457200" cy="457200"/>
-          </a:xfrm>
-          <a:prstGeom prst="ellipse">
-            <a:avLst/>
-          </a:prstGeom>
-          <a:solidFill>
-            <a:schemeClr val="accent1"/>
-          </a:solidFill>
-          <a:ln/>
-        </p:spPr>
-      </p:sp>
-      <p:sp>
-        <p:nvSpPr>
-          <p:cNvPr id="9" name="colh_1"/>
-          <p:cNvSpPr txBox="1"/>
-          <p:nvPr/>
-        </p:nvSpPr>
-        <p:spPr>
-          <a:xfrm>
-            <a:off x="5532120" y="1481328"/>
-            <a:ext cx="2926080" cy="457200"/>
-          </a:xfrm>
-          <a:prstGeom prst="rect">
-            <a:avLst/>
-          </a:prstGeom>
-          <a:noFill/>
-          <a:ln/>
-        </p:spPr>
-        <p:txBody>
-          <a:bodyPr wrap="square" lIns="0" tIns="0" rIns="0" bIns="0" rtlCol="0" anchor="ctr"/>
-          <a:lstStyle/>
-          <a:p>
-            <a:pPr marL="0" indent="0">
-              <a:buNone/>
-            </a:pPr>
-            <a:r>
-              <a:rPr lang="en-US" sz="2000" b="1" dirty="0">
-                <a:solidFill>
-                  <a:schemeClr val="tx1"/>
-                </a:solidFill>
-                <a:latin typeface="Cambria" pitchFamily="34" charset="0"/>
-                <a:ea typeface="Cambria" pitchFamily="34" charset="-122"/>
-                <a:cs typeface="Cambria" pitchFamily="34" charset="-120"/>
-              </a:rPr>
-              <a:t>Our project</a:t>
-            </a:r>
-            <a:endParaRPr lang="en-US" sz="2000" dirty="0"/>
-          </a:p>
-        </p:txBody>
-      </p:sp>
-      <p:sp>
-        <p:nvSpPr>
-          <p:cNvPr id="10" name="colb_1"/>
-          <p:cNvSpPr txBox="1"/>
-          <p:nvPr/>
-        </p:nvSpPr>
-        <p:spPr>
-          <a:xfrm>
-            <a:off x="4937760" y="2194560"/>
-            <a:ext cx="3429000" cy="2286000"/>
-          </a:xfrm>
-          <a:prstGeom prst="rect">
-            <a:avLst/>
-          </a:prstGeom>
-          <a:noFill/>
-          <a:ln/>
-        </p:spPr>
-        <p:txBody>
-          <a:bodyPr wrap="square" lIns="0" tIns="0" rIns="0" bIns="0" rtlCol="0" anchor="t"/>
-          <a:lstStyle/>
-          <a:p>
-            <a:pPr marL="342900" indent="-342900">
-              <a:spcAft>
-                <a:spcPts val="600"/>
-              </a:spcAft>
-              <a:buSzPct val="100000"/>
-              <a:buChar char="•"/>
-            </a:pPr>
-            <a:r>
-              <a:rPr lang="en-US" sz="1400" dirty="0">
-                <a:solidFill>
-                  <a:schemeClr val="tx1"/>
-                </a:solidFill>
-              </a:rPr>
-              <a:t>Kaggle "30,000 Spotify Songs": audio + metadata, no genre tags</a:t>
-            </a:r>
-            <a:endParaRPr lang="en-US" sz="1400" dirty="0"/>
-          </a:p>
-          <a:p>
-            <a:pPr marL="342900" indent="-342900">
-              <a:spcAft>
-                <a:spcPts val="600"/>
-              </a:spcAft>
-              <a:buSzPct val="100000"/>
-              <a:buChar char="•"/>
-            </a:pPr>
-            <a:r>
-              <a:rPr lang="en-US" sz="1400" dirty="0">
-                <a:solidFill>
-                  <a:schemeClr val="tx1"/>
-                </a:solidFill>
-              </a:rPr>
-              <a:t>Same baselines, re-implemented in CV pipelines</a:t>
-            </a:r>
-            <a:endParaRPr lang="en-US" sz="1400" dirty="0"/>
-          </a:p>
-          <a:p>
-            <a:pPr marL="342900" indent="-342900">
-              <a:spcAft>
-                <a:spcPts val="600"/>
-              </a:spcAft>
-              <a:buSzPct val="100000"/>
-              <a:buChar char="•"/>
-            </a:pPr>
-            <a:r>
-              <a:rPr lang="en-US" sz="1400" dirty="0">
-                <a:solidFill>
-                  <a:schemeClr val="tx1"/>
-                </a:solidFill>
-              </a:rPr>
-              <a:t>Plus new features, models, tuning, feature selection</a:t>
-            </a:r>
-            <a:endParaRPr lang="en-US" sz="1400" dirty="0"/>
-          </a:p>
-          <a:p>
-            <a:pPr marL="342900" indent="-342900">
-              <a:spcAft>
-                <a:spcPts val="600"/>
-              </a:spcAft>
-              <a:buSzPct val="100000"/>
-              <a:buChar char="•"/>
-            </a:pPr>
-            <a:r>
-              <a:rPr lang="en-US" sz="1400" dirty="0">
-                <a:solidFill>
-                  <a:schemeClr val="tx1"/>
-                </a:solidFill>
-              </a:rPr>
-              <a:t>Plus a "new playlist" rule and a Streamlit app</a:t>
-            </a:r>
-            <a:endParaRPr lang="en-US" sz="1400" dirty="0"/>
-          </a:p>
-        </p:txBody>
-      </p:sp>
-      <p:sp>
-        <p:nvSpPr>
-          <p:cNvPr id="25" name="Slide Number Placeholder 0"/>
-          <p:cNvSpPr>
-            <a:spLocks noGrp="1"/>
-          </p:cNvSpPr>
-          <p:nvPr>
-            <p:ph type="sldNum" sz="quarter" idx="4294967295"/>
-          </p:nvPr>
-        </p:nvSpPr>
-        <p:spPr>
-          <a:xfrm>
-            <a:off x="8229600" y="4754880"/>
-            <a:ext cx="365760" cy="274320"/>
-          </a:xfrm>
-          <a:prstGeom prst="rect">
-            <a:avLst/>
-          </a:prstGeom>
-          <a:extLst>
-            <a:ext uri="{C572A759-6A51-4108-AA02-DFA0A04FC94B}">
-              <ma14:wrappingTextBoxFlag xmlns="" xmlns:ma14="http://schemas.microsoft.com/office/mac/drawingml/2011/main" val="0"/>
-            </a:ext>
-          </a:extLst>
-        </p:spPr>
-        <p:txBody>
-          <a:bodyPr/>
-          <a:lstStyle>
-            <a:lvl1pPr>
-              <a:defRPr sz="1000">
-                <a:solidFill>
-                  <a:schemeClr val="accent5"/>
-                </a:solidFill>
-              </a:defRPr>
-            </a:lvl1pPr>
-          </a:lstStyle>
-          <a:p>
-            <a:pPr algn="l"/>
-            <a:fld id="{F7021451-1387-4CA6-816F-3879F97B5CBC}" type="slidenum">
-              <a:rPr lang="en-US" b="0"/>
-              <a:t>3</a:t>
-            </a:fld>
-            <a:endParaRPr lang="en-US"/>
-          </a:p>
-        </p:txBody>
-      </p:sp>
-    </p:spTree>
-  </p:cSld>
-  <p:clrMapOvr>
-    <a:masterClrMapping/>
-  </p:clrMapOvr>
-  <p:timing>
-    <p:tnLst>
-      <p:par>
-        <p:cTn id="1" dur="indefinite" restart="never" nodeType="tmRoot"/>
-      </p:par>
-    </p:tnLst>
-  </p:timing>
-</p:sld>
-</file>
-
-<file path=ppt/slides/slide4.xml><?xml version="1.0" encoding="utf-8"?>
-<p:sld xmlns:a="http://schemas.openxmlformats.org/drawingml/2006/main" xmlns:r="http://schemas.openxmlformats.org/officeDocument/2006/relationships" xmlns:p="http://schemas.openxmlformats.org/presentationml/2006/main">
-  <p:cSld>
-    <p:spTree>
-      <p:nvGrpSpPr>
-        <p:cNvPr id="1" name=""/>
-        <p:cNvGrpSpPr/>
-        <p:nvPr/>
-      </p:nvGrpSpPr>
-      <p:grpSpPr>
-        <a:xfrm>
-          <a:off x="0" y="0"/>
-          <a:ext cx="0" cy="0"/>
-          <a:chOff x="0" y="0"/>
-          <a:chExt cx="0" cy="0"/>
-        </a:xfrm>
-      </p:grpSpPr>
-      <p:sp>
-        <p:nvSpPr>
-          <p:cNvPr id="2" name="Title 1"/>
-          <p:cNvSpPr>
-            <a:spLocks noGrp="1"/>
-          </p:cNvSpPr>
-          <p:nvPr>
-            <p:ph type="title" idx="100"/>
-          </p:nvPr>
-        </p:nvSpPr>
-        <p:spPr/>
-        <p:txBody>
-          <a:bodyPr/>
-          <a:lstStyle/>
-          <a:p>
-            <a:r>
-              <a:rPr lang="en-IN" dirty="0" smtClean="0"/>
-              <a:t>R</a:t>
-            </a:r>
-            <a:r>
-              <a:rPr dirty="0" err="1" smtClean="0"/>
-              <a:t>esearch</a:t>
-            </a:r>
-            <a:r>
-              <a:rPr dirty="0" smtClean="0"/>
-              <a:t> paper vs our implementation</a:t>
-            </a:r>
-            <a:endParaRPr dirty="0"/>
           </a:p>
         </p:txBody>
       </p:sp>
       <p:graphicFrame>
         <p:nvGraphicFramePr>
-          <p:cNvPr id="5" name="Table 4"/>
+          <p:cNvPr id="13" name="Table 12">
+            <a:extLst>
+              <a:ext uri="{FF2B5EF4-FFF2-40B4-BE49-F238E27FC236}">
+                <a16:creationId xmlns:a16="http://schemas.microsoft.com/office/drawing/2014/main" id="{3AC586AF-A4AA-159B-6027-1259D685D656}"/>
+              </a:ext>
+            </a:extLst>
+          </p:cNvPr>
           <p:cNvGraphicFramePr>
             <a:graphicFrameLocks noGrp="1"/>
           </p:cNvGraphicFramePr>
           <p:nvPr>
             <p:extLst>
               <p:ext uri="{D42A27DB-BD31-4B8C-83A1-F6EECF244321}">
-                <p14:modId xmlns:p14="http://schemas.microsoft.com/office/powerpoint/2010/main" val="1054967398"/>
+                <p14:modId xmlns:p14="http://schemas.microsoft.com/office/powerpoint/2010/main" val="1967678040"/>
               </p:ext>
             </p:extLst>
           </p:nvPr>
         </p:nvGraphicFramePr>
         <p:xfrm>
           <a:off x="548640" y="1171955"/>
-          <a:ext cx="7391400" cy="2946655"/>
+          <a:ext cx="7391400" cy="2687575"/>
         </p:xfrm>
         <a:graphic>
           <a:graphicData uri="http://schemas.openxmlformats.org/drawingml/2006/table">
@@ -8611,7 +7782,15 @@
                       </a:pPr>
                       <a:r>
                         <a:rPr dirty="0"/>
-                        <a:t>Research paper (2018)</a:t>
+                        <a:t>Research paper</a:t>
+                      </a:r>
+                      <a:r>
+                        <a:rPr lang="en-IN" dirty="0"/>
+                        <a:t> (Stanford)</a:t>
+                      </a:r>
+                      <a:r>
+                        <a:rPr dirty="0"/>
+                        <a:t> (2018)</a:t>
                       </a:r>
                     </a:p>
                   </a:txBody>
@@ -8638,6 +7817,7 @@
                         </a:defRPr>
                       </a:pPr>
                       <a:r>
+                        <a:rPr dirty="0"/>
                         <a:t>Our project</a:t>
                       </a:r>
                     </a:p>
@@ -8727,7 +7907,37 @@
                         </a:defRPr>
                       </a:pPr>
                       <a:r>
-                        <a:t>Kaggle Spotify dataset; 676 deduplicated tracks across 13 playlists</a:t>
+                        <a:rPr dirty="0"/>
+                        <a:t>Kaggle Spotify dataset</a:t>
+                      </a:r>
+                      <a:r>
+                        <a:rPr lang="en-IN" dirty="0"/>
+                        <a:t>, </a:t>
+                      </a:r>
+                      <a:r>
+                        <a:rPr lang="en-US" sz="1100" dirty="0">
+                          <a:solidFill>
+                            <a:schemeClr val="tx1"/>
+                          </a:solidFill>
+                        </a:rPr>
+                        <a:t>"30,000 Spotify Songs“ </a:t>
+                      </a:r>
+                    </a:p>
+                    <a:p>
+                      <a:pPr>
+                        <a:spcAft>
+                          <a:spcPts val="0"/>
+                        </a:spcAft>
+                        <a:defRPr sz="1100" b="0">
+                          <a:solidFill>
+                            <a:srgbClr val="2D343C"/>
+                          </a:solidFill>
+                          <a:latin typeface="Aptos"/>
+                        </a:defRPr>
+                      </a:pPr>
+                      <a:r>
+                        <a:rPr dirty="0"/>
+                        <a:t>676 deduplicated tracks across 13 playlists</a:t>
                       </a:r>
                     </a:p>
                   </a:txBody>
@@ -8815,6 +8025,7 @@
                         </a:defRPr>
                       </a:pPr>
                       <a:r>
+                        <a:rPr dirty="0"/>
                         <a:t>Audio features + engineered ratios + metadata; no per-track genre tags</a:t>
                       </a:r>
                     </a:p>
@@ -8876,7 +8087,16 @@
                         </a:defRPr>
                       </a:pPr>
                       <a:r>
-                        <a:t>Perceptron, SVM variants, neural network</a:t>
+                        <a:rPr dirty="0"/>
+                        <a:t>Perceptron, SVM variants, </a:t>
+                      </a:r>
+                      <a:r>
+                        <a:rPr lang="en-IN" dirty="0"/>
+                        <a:t>1-hidden-layer </a:t>
+                      </a:r>
+                      <a:r>
+                        <a:rPr dirty="0"/>
+                        <a:t>neural network</a:t>
                       </a:r>
                     </a:p>
                   </a:txBody>
@@ -8903,7 +8123,32 @@
                         </a:defRPr>
                       </a:pPr>
                       <a:r>
-                        <a:t>Reimplemented baselines; tuned SVM, MLP, HistGradientBoosting, Random Forest</a:t>
+                        <a:rPr dirty="0"/>
+                        <a:t>Reimplemented baselines</a:t>
+                      </a:r>
+                      <a:r>
+                        <a:rPr lang="en-IN" dirty="0"/>
+                        <a:t> </a:t>
+                      </a:r>
+                      <a:r>
+                        <a:rPr lang="en-US" sz="1100" dirty="0">
+                          <a:solidFill>
+                            <a:schemeClr val="tx1"/>
+                          </a:solidFill>
+                        </a:rPr>
+                        <a:t>in CV pipelines</a:t>
+                      </a:r>
+                      <a:r>
+                        <a:rPr dirty="0"/>
+                        <a:t>; tuned SVM, MLP, </a:t>
+                      </a:r>
+                      <a:r>
+                        <a:rPr dirty="0" err="1"/>
+                        <a:t>HistGradientBoosting</a:t>
+                      </a:r>
+                      <a:r>
+                        <a:rPr dirty="0"/>
+                        <a:t>, Random Forest</a:t>
                       </a:r>
                     </a:p>
                   </a:txBody>
@@ -8916,88 +8161,6 @@
                 <a:extLst>
                   <a:ext uri="{0D108BD9-81ED-4DB2-BD59-A6C34878D82A}">
                     <a16:rowId xmlns:a16="http://schemas.microsoft.com/office/drawing/2014/main" val="10003"/>
-                  </a:ext>
-                </a:extLst>
-              </a:tr>
-              <a:tr h="0">
-                <a:tc>
-                  <a:txBody>
-                    <a:bodyPr/>
-                    <a:lstStyle/>
-                    <a:p>
-                      <a:pPr>
-                        <a:spcAft>
-                          <a:spcPts val="0"/>
-                        </a:spcAft>
-                        <a:defRPr sz="1100" b="1">
-                          <a:solidFill>
-                            <a:srgbClr val="193052"/>
-                          </a:solidFill>
-                          <a:latin typeface="Aptos"/>
-                        </a:defRPr>
-                      </a:pPr>
-                      <a:endParaRPr dirty="0"/>
-                    </a:p>
-                  </a:txBody>
-                  <a:tcPr anchor="ctr">
-                    <a:solidFill>
-                      <a:srgbClr val="F7F9FC"/>
-                    </a:solidFill>
-                  </a:tcPr>
-                </a:tc>
-                <a:tc>
-                  <a:txBody>
-                    <a:bodyPr/>
-                    <a:lstStyle/>
-                    <a:p>
-                      <a:pPr>
-                        <a:spcAft>
-                          <a:spcPts val="0"/>
-                        </a:spcAft>
-                        <a:defRPr sz="1100" b="0">
-                          <a:solidFill>
-                            <a:srgbClr val="2D343C"/>
-                          </a:solidFill>
-                          <a:latin typeface="Aptos"/>
-                        </a:defRPr>
-                      </a:pPr>
-                      <a:endParaRPr dirty="0"/>
-                    </a:p>
-                  </a:txBody>
-                  <a:tcPr anchor="ctr">
-                    <a:solidFill>
-                      <a:srgbClr val="F7F9FC"/>
-                    </a:solidFill>
-                  </a:tcPr>
-                </a:tc>
-                <a:tc>
-                  <a:txBody>
-                    <a:bodyPr/>
-                    <a:lstStyle/>
-                    <a:p>
-                      <a:pPr>
-                        <a:spcAft>
-                          <a:spcPts val="0"/>
-                        </a:spcAft>
-                        <a:defRPr sz="1100" b="0">
-                          <a:solidFill>
-                            <a:srgbClr val="2D343C"/>
-                          </a:solidFill>
-                          <a:latin typeface="Aptos"/>
-                        </a:defRPr>
-                      </a:pPr>
-                      <a:endParaRPr dirty="0"/>
-                    </a:p>
-                  </a:txBody>
-                  <a:tcPr anchor="ctr">
-                    <a:solidFill>
-                      <a:srgbClr val="F7F9FC"/>
-                    </a:solidFill>
-                  </a:tcPr>
-                </a:tc>
-                <a:extLst>
-                  <a:ext uri="{0D108BD9-81ED-4DB2-BD59-A6C34878D82A}">
-                    <a16:rowId xmlns:a16="http://schemas.microsoft.com/office/drawing/2014/main" val="10004"/>
                   </a:ext>
                 </a:extLst>
               </a:tr>
@@ -9019,6 +8182,7 @@
                         </a:defRPr>
                       </a:pPr>
                       <a:r>
+                        <a:rPr dirty="0"/>
                         <a:t>Evaluation</a:t>
                       </a:r>
                     </a:p>
@@ -9073,6 +8237,7 @@
                         </a:defRPr>
                       </a:pPr>
                       <a:r>
+                        <a:rPr dirty="0"/>
                         <a:t>Stratified 80/20 split; tuning/feature selection on training data with CV; held-out test reported once</a:t>
                       </a:r>
                     </a:p>
@@ -9107,6 +8272,7 @@
                         </a:defRPr>
                       </a:pPr>
                       <a:r>
+                        <a:rPr lang="en-US"/>
                         <a:t>Product output</a:t>
                       </a:r>
                     </a:p>
@@ -9134,9 +8300,10 @@
                         </a:defRPr>
                       </a:pPr>
                       <a:r>
-                        <a:rPr dirty="0"/>
+                        <a:rPr lang="en-US"/>
                         <a:t>Classify a song into a playlist or suggest a new playlist as the problem goal</a:t>
                       </a:r>
+                      <a:endParaRPr lang="en-US" dirty="0"/>
                     </a:p>
                   </a:txBody>
                   <a:tcPr anchor="ctr">
@@ -9162,15 +8329,15 @@
                         </a:defRPr>
                       </a:pPr>
                       <a:r>
-                        <a:rPr dirty="0"/>
+                        <a:rPr lang="en-US" dirty="0"/>
                         <a:t>Top-3 playlist probabilities plus confidence-threshold-based new-playlist suggestion in a </a:t>
                       </a:r>
                       <a:r>
-                        <a:rPr dirty="0" err="1"/>
+                        <a:rPr lang="en-US" dirty="0" err="1"/>
                         <a:t>Streamlit</a:t>
                       </a:r>
                       <a:r>
-                        <a:rPr dirty="0"/>
+                        <a:rPr lang="en-US" dirty="0"/>
                         <a:t> app</a:t>
                       </a:r>
                     </a:p>
@@ -9191,101 +8358,20 @@
           </a:graphicData>
         </a:graphic>
       </p:graphicFrame>
-      <p:sp>
-        <p:nvSpPr>
-          <p:cNvPr id="6" name="Rectangle 5"/>
-          <p:cNvSpPr/>
-          <p:nvPr/>
-        </p:nvSpPr>
-        <p:spPr>
-          <a:xfrm>
-            <a:off x="502920" y="6510528"/>
-            <a:ext cx="11109960" cy="16459"/>
-          </a:xfrm>
-          <a:prstGeom prst="rect">
-            <a:avLst/>
-          </a:prstGeom>
-          <a:solidFill>
-            <a:srgbClr val="EBF2F9"/>
-          </a:solidFill>
-          <a:ln>
-            <a:noFill/>
-          </a:ln>
-        </p:spPr>
-        <p:style>
-          <a:lnRef idx="1">
-            <a:schemeClr val="accent1"/>
-          </a:lnRef>
-          <a:fillRef idx="3">
-            <a:schemeClr val="accent1"/>
-          </a:fillRef>
-          <a:effectRef idx="2">
-            <a:schemeClr val="accent1"/>
-          </a:effectRef>
-          <a:fontRef idx="minor">
-            <a:schemeClr val="lt1"/>
-          </a:fontRef>
-        </p:style>
-        <p:txBody>
-          <a:bodyPr rtlCol="0" anchor="ctr"/>
-          <a:lstStyle/>
-          <a:p>
-            <a:pPr algn="ctr"/>
-            <a:endParaRPr/>
-          </a:p>
-        </p:txBody>
-      </p:sp>
-      <p:sp>
-        <p:nvSpPr>
-          <p:cNvPr id="7" name="TextBox 6"/>
-          <p:cNvSpPr txBox="1"/>
-          <p:nvPr/>
-        </p:nvSpPr>
-        <p:spPr>
-          <a:xfrm>
-            <a:off x="11155680" y="6556248"/>
-            <a:ext cx="411480" cy="164592"/>
-          </a:xfrm>
-          <a:prstGeom prst="rect">
-            <a:avLst/>
-          </a:prstGeom>
-          <a:noFill/>
-        </p:spPr>
-        <p:txBody>
-          <a:bodyPr wrap="none">
-            <a:spAutoFit/>
-          </a:bodyPr>
-          <a:lstStyle/>
-          <a:p>
-            <a:pPr algn="r">
-              <a:defRPr sz="900">
-                <a:solidFill>
-                  <a:srgbClr val="5F6976"/>
-                </a:solidFill>
-              </a:defRPr>
-            </a:pPr>
-            <a:r>
-              <a:t>4</a:t>
-            </a:r>
-          </a:p>
-        </p:txBody>
-      </p:sp>
     </p:spTree>
+    <p:extLst>
+      <p:ext uri="{BB962C8B-B14F-4D97-AF65-F5344CB8AC3E}">
+        <p14:creationId xmlns:p14="http://schemas.microsoft.com/office/powerpoint/2010/main" val="470184268"/>
+      </p:ext>
+    </p:extLst>
   </p:cSld>
   <p:clrMapOvr>
     <a:masterClrMapping/>
   </p:clrMapOvr>
-  <p:timing>
-    <p:tnLst>
-      <p:par>
-        <p:cTn id="1" dur="indefinite" restart="never" nodeType="tmRoot"/>
-      </p:par>
-    </p:tnLst>
-  </p:timing>
 </p:sld>
 </file>
 
-<file path=ppt/slides/slide5.xml><?xml version="1.0" encoding="utf-8"?>
+<file path=ppt/slides/slide4.xml><?xml version="1.0" encoding="utf-8"?>
 <p:sld xmlns:a="http://schemas.openxmlformats.org/drawingml/2006/main" xmlns:r="http://schemas.openxmlformats.org/officeDocument/2006/relationships" xmlns:p="http://schemas.openxmlformats.org/presentationml/2006/main">
   <p:cSld name="Slide 4">
     <p:spTree>
@@ -9943,67 +9029,15 @@
           </a:p>
         </p:txBody>
       </p:sp>
-      <p:sp>
-        <p:nvSpPr>
-          <p:cNvPr id="25" name="Slide Number Placeholder 0"/>
-          <p:cNvSpPr>
-            <a:spLocks noGrp="1"/>
-          </p:cNvSpPr>
-          <p:nvPr>
-            <p:ph type="sldNum" sz="quarter" idx="4294967295"/>
-          </p:nvPr>
-        </p:nvSpPr>
-        <p:spPr>
-          <a:xfrm>
-            <a:off x="8229600" y="4754880"/>
-            <a:ext cx="365760" cy="274320"/>
-          </a:xfrm>
-          <a:prstGeom prst="rect">
-            <a:avLst/>
-          </a:prstGeom>
-          <a:extLst>
-            <a:ext uri="{C572A759-6A51-4108-AA02-DFA0A04FC94B}">
-              <ma14:wrappingTextBoxFlag xmlns="" xmlns:ma14="http://schemas.microsoft.com/office/mac/drawingml/2011/main" val="0"/>
-            </a:ext>
-          </a:extLst>
-        </p:spPr>
-        <p:txBody>
-          <a:bodyPr/>
-          <a:lstStyle>
-            <a:lvl1pPr>
-              <a:defRPr sz="1000">
-                <a:solidFill>
-                  <a:schemeClr val="accent5"/>
-                </a:solidFill>
-              </a:defRPr>
-            </a:lvl1pPr>
-          </a:lstStyle>
-          <a:p>
-            <a:pPr algn="l"/>
-            <a:fld id="{F7021451-1387-4CA6-816F-3879F97B5CBC}" type="slidenum">
-              <a:rPr lang="en-US" b="0"/>
-              <a:t>5</a:t>
-            </a:fld>
-            <a:endParaRPr lang="en-US"/>
-          </a:p>
-        </p:txBody>
-      </p:sp>
     </p:spTree>
   </p:cSld>
   <p:clrMapOvr>
     <a:masterClrMapping/>
   </p:clrMapOvr>
-  <p:timing>
-    <p:tnLst>
-      <p:par>
-        <p:cTn id="1" dur="indefinite" restart="never" nodeType="tmRoot"/>
-      </p:par>
-    </p:tnLst>
-  </p:timing>
 </p:sld>
 </file>
 
-<file path=ppt/slides/slide6.xml><?xml version="1.0" encoding="utf-8"?>
+<file path=ppt/slides/slide5.xml><?xml version="1.0" encoding="utf-8"?>
 <p:sld xmlns:a="http://schemas.openxmlformats.org/drawingml/2006/main" xmlns:r="http://schemas.openxmlformats.org/officeDocument/2006/relationships" xmlns:p="http://schemas.openxmlformats.org/presentationml/2006/main">
   <p:cSld name="Slide 5">
     <p:spTree>
@@ -11091,67 +10125,15 @@
           </a:p>
         </p:txBody>
       </p:sp>
-      <p:sp>
-        <p:nvSpPr>
-          <p:cNvPr id="37" name="Slide Number Placeholder 0"/>
-          <p:cNvSpPr>
-            <a:spLocks noGrp="1"/>
-          </p:cNvSpPr>
-          <p:nvPr>
-            <p:ph type="sldNum" sz="quarter" idx="4294967295"/>
-          </p:nvPr>
-        </p:nvSpPr>
-        <p:spPr>
-          <a:xfrm>
-            <a:off x="8229600" y="4754880"/>
-            <a:ext cx="365760" cy="274320"/>
-          </a:xfrm>
-          <a:prstGeom prst="rect">
-            <a:avLst/>
-          </a:prstGeom>
-          <a:extLst>
-            <a:ext uri="{C572A759-6A51-4108-AA02-DFA0A04FC94B}">
-              <ma14:wrappingTextBoxFlag xmlns="" xmlns:ma14="http://schemas.microsoft.com/office/mac/drawingml/2011/main" val="0"/>
-            </a:ext>
-          </a:extLst>
-        </p:spPr>
-        <p:txBody>
-          <a:bodyPr/>
-          <a:lstStyle>
-            <a:lvl1pPr>
-              <a:defRPr sz="1000">
-                <a:solidFill>
-                  <a:schemeClr val="accent5"/>
-                </a:solidFill>
-              </a:defRPr>
-            </a:lvl1pPr>
-          </a:lstStyle>
-          <a:p>
-            <a:pPr algn="l"/>
-            <a:fld id="{F7021451-1387-4CA6-816F-3879F97B5CBC}" type="slidenum">
-              <a:rPr lang="en-US" b="0"/>
-              <a:t>6</a:t>
-            </a:fld>
-            <a:endParaRPr lang="en-US"/>
-          </a:p>
-        </p:txBody>
-      </p:sp>
     </p:spTree>
   </p:cSld>
   <p:clrMapOvr>
     <a:masterClrMapping/>
   </p:clrMapOvr>
-  <p:timing>
-    <p:tnLst>
-      <p:par>
-        <p:cTn id="1" dur="indefinite" restart="never" nodeType="tmRoot"/>
-      </p:par>
-    </p:tnLst>
-  </p:timing>
 </p:sld>
 </file>
 
-<file path=ppt/slides/slide7.xml><?xml version="1.0" encoding="utf-8"?>
+<file path=ppt/slides/slide6.xml><?xml version="1.0" encoding="utf-8"?>
 <p:sld xmlns:a="http://schemas.openxmlformats.org/drawingml/2006/main" xmlns:r="http://schemas.openxmlformats.org/officeDocument/2006/relationships" xmlns:p="http://schemas.openxmlformats.org/presentationml/2006/main">
   <p:cSld name="Slide 6">
     <p:spTree>
@@ -11374,67 +10356,15 @@
           </a:p>
         </p:txBody>
       </p:sp>
-      <p:sp>
-        <p:nvSpPr>
-          <p:cNvPr id="25" name="Slide Number Placeholder 0"/>
-          <p:cNvSpPr>
-            <a:spLocks noGrp="1"/>
-          </p:cNvSpPr>
-          <p:nvPr>
-            <p:ph type="sldNum" sz="quarter" idx="4294967295"/>
-          </p:nvPr>
-        </p:nvSpPr>
-        <p:spPr>
-          <a:xfrm>
-            <a:off x="8229600" y="4754880"/>
-            <a:ext cx="365760" cy="274320"/>
-          </a:xfrm>
-          <a:prstGeom prst="rect">
-            <a:avLst/>
-          </a:prstGeom>
-          <a:extLst>
-            <a:ext uri="{C572A759-6A51-4108-AA02-DFA0A04FC94B}">
-              <ma14:wrappingTextBoxFlag xmlns="" xmlns:ma14="http://schemas.microsoft.com/office/mac/drawingml/2011/main" val="0"/>
-            </a:ext>
-          </a:extLst>
-        </p:spPr>
-        <p:txBody>
-          <a:bodyPr/>
-          <a:lstStyle>
-            <a:lvl1pPr>
-              <a:defRPr sz="1000">
-                <a:solidFill>
-                  <a:schemeClr val="accent5"/>
-                </a:solidFill>
-              </a:defRPr>
-            </a:lvl1pPr>
-          </a:lstStyle>
-          <a:p>
-            <a:pPr algn="l"/>
-            <a:fld id="{F7021451-1387-4CA6-816F-3879F97B5CBC}" type="slidenum">
-              <a:rPr lang="en-US" b="0"/>
-              <a:t>7</a:t>
-            </a:fld>
-            <a:endParaRPr lang="en-US"/>
-          </a:p>
-        </p:txBody>
-      </p:sp>
     </p:spTree>
   </p:cSld>
   <p:clrMapOvr>
     <a:masterClrMapping/>
   </p:clrMapOvr>
-  <p:timing>
-    <p:tnLst>
-      <p:par>
-        <p:cTn id="1" dur="indefinite" restart="never" nodeType="tmRoot"/>
-      </p:par>
-    </p:tnLst>
-  </p:timing>
 </p:sld>
 </file>
 
-<file path=ppt/slides/slide8.xml><?xml version="1.0" encoding="utf-8"?>
+<file path=ppt/slides/slide7.xml><?xml version="1.0" encoding="utf-8"?>
 <p:sld xmlns:a="http://schemas.openxmlformats.org/drawingml/2006/main" xmlns:r="http://schemas.openxmlformats.org/officeDocument/2006/relationships" xmlns:p="http://schemas.openxmlformats.org/presentationml/2006/main">
   <p:cSld name="Slide 7">
     <p:spTree>
@@ -11825,67 +10755,15 @@
           </a:p>
         </p:txBody>
       </p:sp>
-      <p:sp>
-        <p:nvSpPr>
-          <p:cNvPr id="25" name="Slide Number Placeholder 0"/>
-          <p:cNvSpPr>
-            <a:spLocks noGrp="1"/>
-          </p:cNvSpPr>
-          <p:nvPr>
-            <p:ph type="sldNum" sz="quarter" idx="4294967295"/>
-          </p:nvPr>
-        </p:nvSpPr>
-        <p:spPr>
-          <a:xfrm>
-            <a:off x="8229600" y="4754880"/>
-            <a:ext cx="365760" cy="274320"/>
-          </a:xfrm>
-          <a:prstGeom prst="rect">
-            <a:avLst/>
-          </a:prstGeom>
-          <a:extLst>
-            <a:ext uri="{C572A759-6A51-4108-AA02-DFA0A04FC94B}">
-              <ma14:wrappingTextBoxFlag xmlns="" xmlns:ma14="http://schemas.microsoft.com/office/mac/drawingml/2011/main" val="0"/>
-            </a:ext>
-          </a:extLst>
-        </p:spPr>
-        <p:txBody>
-          <a:bodyPr/>
-          <a:lstStyle>
-            <a:lvl1pPr>
-              <a:defRPr sz="1000">
-                <a:solidFill>
-                  <a:schemeClr val="accent5"/>
-                </a:solidFill>
-              </a:defRPr>
-            </a:lvl1pPr>
-          </a:lstStyle>
-          <a:p>
-            <a:pPr algn="l"/>
-            <a:fld id="{F7021451-1387-4CA6-816F-3879F97B5CBC}" type="slidenum">
-              <a:rPr lang="en-US" b="0"/>
-              <a:t>8</a:t>
-            </a:fld>
-            <a:endParaRPr lang="en-US"/>
-          </a:p>
-        </p:txBody>
-      </p:sp>
     </p:spTree>
   </p:cSld>
   <p:clrMapOvr>
     <a:masterClrMapping/>
   </p:clrMapOvr>
-  <p:timing>
-    <p:tnLst>
-      <p:par>
-        <p:cTn id="1" dur="indefinite" restart="never" nodeType="tmRoot"/>
-      </p:par>
-    </p:tnLst>
-  </p:timing>
 </p:sld>
 </file>
 
-<file path=ppt/slides/slide9.xml><?xml version="1.0" encoding="utf-8"?>
+<file path=ppt/slides/slide8.xml><?xml version="1.0" encoding="utf-8"?>
 <p:sld xmlns:a="http://schemas.openxmlformats.org/drawingml/2006/main" xmlns:r="http://schemas.openxmlformats.org/officeDocument/2006/relationships" xmlns:p="http://schemas.openxmlformats.org/presentationml/2006/main">
   <p:cSld name="Slide 8">
     <p:spTree>
@@ -12183,63 +11061,152 @@
           </a:p>
         </p:txBody>
       </p:sp>
-      <p:sp>
-        <p:nvSpPr>
-          <p:cNvPr id="25" name="Slide Number Placeholder 0"/>
-          <p:cNvSpPr>
-            <a:spLocks noGrp="1"/>
-          </p:cNvSpPr>
-          <p:nvPr>
-            <p:ph type="sldNum" sz="quarter" idx="4294967295"/>
-          </p:nvPr>
-        </p:nvSpPr>
-        <p:spPr>
-          <a:xfrm>
-            <a:off x="8229600" y="4754880"/>
-            <a:ext cx="365760" cy="274320"/>
-          </a:xfrm>
-          <a:prstGeom prst="rect">
-            <a:avLst/>
-          </a:prstGeom>
-          <a:extLst>
-            <a:ext uri="{C572A759-6A51-4108-AA02-DFA0A04FC94B}">
-              <ma14:wrappingTextBoxFlag xmlns="" xmlns:ma14="http://schemas.microsoft.com/office/mac/drawingml/2011/main" val="0"/>
-            </a:ext>
-          </a:extLst>
-        </p:spPr>
-        <p:txBody>
-          <a:bodyPr/>
-          <a:lstStyle>
-            <a:lvl1pPr>
-              <a:defRPr sz="1000">
-                <a:solidFill>
-                  <a:schemeClr val="accent5"/>
-                </a:solidFill>
-              </a:defRPr>
-            </a:lvl1pPr>
-          </a:lstStyle>
-          <a:p>
-            <a:pPr algn="l"/>
-            <a:fld id="{F7021451-1387-4CA6-816F-3879F97B5CBC}" type="slidenum">
-              <a:rPr lang="en-US" b="0"/>
-              <a:t>9</a:t>
-            </a:fld>
-            <a:endParaRPr lang="en-US"/>
-          </a:p>
-        </p:txBody>
-      </p:sp>
     </p:spTree>
   </p:cSld>
   <p:clrMapOvr>
     <a:masterClrMapping/>
   </p:clrMapOvr>
-  <p:timing>
-    <p:tnLst>
-      <p:par>
-        <p:cTn id="1" dur="indefinite" restart="never" nodeType="tmRoot"/>
-      </p:par>
-    </p:tnLst>
-  </p:timing>
+</p:sld>
+</file>
+
+<file path=ppt/slides/slide9.xml><?xml version="1.0" encoding="utf-8"?>
+<p:sld xmlns:a="http://schemas.openxmlformats.org/drawingml/2006/main" xmlns:r="http://schemas.openxmlformats.org/officeDocument/2006/relationships" xmlns:p="http://schemas.openxmlformats.org/presentationml/2006/main">
+  <p:cSld name="Slide 9">
+    <p:spTree>
+      <p:nvGrpSpPr>
+        <p:cNvPr id="1" name=""/>
+        <p:cNvGrpSpPr/>
+        <p:nvPr/>
+      </p:nvGrpSpPr>
+      <p:grpSpPr>
+        <a:xfrm>
+          <a:off x="0" y="0"/>
+          <a:ext cx="0" cy="0"/>
+          <a:chOff x="0" y="0"/>
+          <a:chExt cx="0" cy="0"/>
+        </a:xfrm>
+      </p:grpSpPr>
+      <p:sp>
+        <p:nvSpPr>
+          <p:cNvPr id="2" name="Text 0"/>
+          <p:cNvSpPr>
+            <a:spLocks noGrp="1"/>
+          </p:cNvSpPr>
+          <p:nvPr>
+            <p:ph type="title" idx="100" hasCustomPrompt="1"/>
+          </p:nvPr>
+        </p:nvSpPr>
+        <p:spPr>
+          <a:xfrm>
+            <a:off x="548640" y="274320"/>
+            <a:ext cx="8046720" cy="731520"/>
+          </a:xfrm>
+          <a:prstGeom prst="rect">
+            <a:avLst/>
+          </a:prstGeom>
+          <a:noFill/>
+          <a:ln/>
+        </p:spPr>
+        <p:txBody>
+          <a:bodyPr wrap="square" lIns="0" tIns="0" rIns="0" bIns="0" rtlCol="0" anchor="ctr"/>
+          <a:lstStyle/>
+          <a:p>
+            <a:pPr marL="0" indent="0" algn="l">
+              <a:buNone/>
+            </a:pPr>
+            <a:r>
+              <a:rPr lang="en-US" sz="3000" b="1" dirty="0">
+                <a:solidFill>
+                  <a:schemeClr val="tx1"/>
+                </a:solidFill>
+              </a:rPr>
+              <a:t>What drives it, what confuses it</a:t>
+            </a:r>
+            <a:endParaRPr lang="en-US" sz="3000" dirty="0"/>
+          </a:p>
+        </p:txBody>
+      </p:sp>
+      <p:graphicFrame>
+        <p:nvGraphicFramePr>
+          <p:cNvPr id="3" name="Chart 0"/>
+          <p:cNvGraphicFramePr/>
+          <p:nvPr/>
+        </p:nvGraphicFramePr>
+        <p:xfrm>
+          <a:off x="365760" y="1097280"/>
+          <a:ext cx="4023360" cy="3017520"/>
+        </p:xfrm>
+        <a:graphic>
+          <a:graphicData uri="http://schemas.openxmlformats.org/drawingml/2006/chart">
+            <c:chart xmlns:c="http://schemas.openxmlformats.org/drawingml/2006/chart" xmlns:r="http://schemas.openxmlformats.org/officeDocument/2006/relationships" r:id="rId3"/>
+          </a:graphicData>
+        </a:graphic>
+      </p:graphicFrame>
+      <p:pic>
+        <p:nvPicPr>
+          <p:cNvPr id="4" name="Image 0" descr="Normalised confusion matrix of the final Random Forest on the test set"/>
+          <p:cNvPicPr>
+            <a:picLocks noChangeAspect="1"/>
+          </p:cNvPicPr>
+          <p:nvPr/>
+        </p:nvPicPr>
+        <p:blipFill>
+          <a:blip r:embed="rId4"/>
+          <a:stretch>
+            <a:fillRect/>
+          </a:stretch>
+        </p:blipFill>
+        <p:spPr>
+          <a:xfrm>
+            <a:off x="4526280" y="1097280"/>
+            <a:ext cx="4206240" cy="3569205"/>
+          </a:xfrm>
+          <a:prstGeom prst="rect">
+            <a:avLst/>
+          </a:prstGeom>
+        </p:spPr>
+      </p:pic>
+      <p:sp>
+        <p:nvSpPr>
+          <p:cNvPr id="5" name="drivers_note"/>
+          <p:cNvSpPr txBox="1"/>
+          <p:nvPr/>
+        </p:nvSpPr>
+        <p:spPr>
+          <a:xfrm>
+            <a:off x="548640" y="4114800"/>
+            <a:ext cx="4023360" cy="594360"/>
+          </a:xfrm>
+          <a:prstGeom prst="rect">
+            <a:avLst/>
+          </a:prstGeom>
+          <a:noFill/>
+          <a:ln/>
+        </p:spPr>
+        <p:txBody>
+          <a:bodyPr wrap="square" lIns="0" tIns="0" rIns="0" bIns="0" rtlCol="0" anchor="t"/>
+          <a:lstStyle/>
+          <a:p>
+            <a:pPr marL="0" indent="0">
+              <a:buNone/>
+            </a:pPr>
+            <a:r>
+              <a:rPr lang="en-US" sz="1200" dirty="0">
+                <a:solidFill>
+                  <a:schemeClr val="tx1"/>
+                </a:solidFill>
+              </a:rPr>
+              <a:t>release_year dominates: several playlists are era-themed. Near-duplicate playlists (Charts 2020 vs 2020 Hits, Neo-Soul vs Urban Contemporary) get mixed up.</a:t>
+            </a:r>
+            <a:endParaRPr lang="en-US" sz="1200" dirty="0"/>
+          </a:p>
+        </p:txBody>
+      </p:sp>
+    </p:spTree>
+  </p:cSld>
+  <p:clrMapOvr>
+    <a:masterClrMapping/>
+  </p:clrMapOvr>
 </p:sld>
 </file>
 

</xml_diff>